<commit_message>
correzione power point seminario
</commit_message>
<xml_diff>
--- a/SEMINARIO/MEV.pptx
+++ b/SEMINARIO/MEV.pptx
@@ -5528,7 +5528,7 @@
 <dgm:dataModel xmlns:dgm="http://schemas.openxmlformats.org/drawingml/2006/diagram" xmlns:a="http://schemas.openxmlformats.org/drawingml/2006/main">
   <dgm:ptLst>
     <dgm:pt modelId="{E69D3792-D02C-4300-8235-67DB909F6BE9}" type="doc">
-      <dgm:prSet loTypeId="urn:microsoft.com/office/officeart/2008/layout/LinedList" loCatId="list" qsTypeId="urn:microsoft.com/office/officeart/2005/8/quickstyle/simple1" qsCatId="simple" csTypeId="urn:microsoft.com/office/officeart/2005/8/colors/colorful5" csCatId="colorful"/>
+      <dgm:prSet loTypeId="urn:microsoft.com/office/officeart/2008/layout/LinedList" loCatId="list" qsTypeId="urn:microsoft.com/office/officeart/2005/8/quickstyle/simple1" qsCatId="simple" csTypeId="urn:microsoft.com/office/officeart/2005/8/colors/colorful5" csCatId="colorful" phldr="1"/>
       <dgm:spPr/>
       <dgm:t>
         <a:bodyPr/>
@@ -5575,19 +5575,27 @@
       </dgm:t>
     </dgm:pt>
     <dgm:pt modelId="{C05165C9-9A71-419E-9DC8-8C64E3F96975}">
-      <dgm:prSet/>
+      <dgm:prSet custT="1"/>
       <dgm:spPr/>
       <dgm:t>
         <a:bodyPr/>
         <a:lstStyle/>
         <a:p>
           <a:r>
-            <a:rPr lang="en-US" b="1" dirty="0"/>
-            <a:t>Preventing or reducing MEV</a:t>
+            <a:rPr lang="en-US" sz="2000" b="1" dirty="0"/>
+            <a:t>Prevention/Reduction</a:t>
           </a:r>
           <a:r>
-            <a:rPr lang="en-US" dirty="0"/>
-            <a:t>: limit opportunities for MEV extraction</a:t>
+            <a:rPr lang="en-US" sz="2000" dirty="0"/>
+            <a:t>: try to eliminate or reduce MEV </a:t>
+          </a:r>
+          <a:r>
+            <a:rPr lang="en-US" sz="2000" u="none" dirty="0"/>
+            <a:t>opportunities</a:t>
+          </a:r>
+          <a:r>
+            <a:rPr lang="en-US" sz="2000" dirty="0"/>
+            <a:t>.</a:t>
           </a:r>
         </a:p>
       </dgm:t>
@@ -5615,19 +5623,19 @@
       </dgm:t>
     </dgm:pt>
     <dgm:pt modelId="{6E943DAE-56CA-4AE0-B330-547D7417C7C9}">
-      <dgm:prSet/>
+      <dgm:prSet custT="1"/>
       <dgm:spPr/>
       <dgm:t>
         <a:bodyPr/>
         <a:lstStyle/>
         <a:p>
           <a:r>
-            <a:rPr lang="en-US" b="1"/>
-            <a:t>Reducing its side effects</a:t>
+            <a:rPr lang="en-US" sz="2000" b="1" dirty="0"/>
+            <a:t>Side-effects Reduction</a:t>
           </a:r>
           <a:r>
-            <a:rPr lang="en-US"/>
-            <a:t>: try to make it less harmful and less centralized</a:t>
+            <a:rPr lang="en-US" sz="2000" dirty="0"/>
+            <a:t>: try to reduce the negative effects.</a:t>
           </a:r>
         </a:p>
       </dgm:t>
@@ -5975,8 +5983,8 @@
         </a:p>
       </dgm:t>
     </dgm:pt>
-    <mc:AlternateContent xmlns:mc="http://schemas.openxmlformats.org/markup-compatibility/2006">
-      <mc:Choice xmlns:a14="http://schemas.microsoft.com/office/drawing/2010/main" Requires="a14">
+    <mc:AlternateContent xmlns:mc="http://schemas.openxmlformats.org/markup-compatibility/2006" xmlns:a14="http://schemas.microsoft.com/office/drawing/2010/main">
+      <mc:Choice Requires="a14">
         <dgm:pt modelId="{8675E681-D1E7-479B-A7B7-BE5042201E9A}">
           <dgm:prSet phldrT="[Testo]" custT="1"/>
           <dgm:spPr/>
@@ -6042,7 +6050,7 @@
           </dgm:t>
         </dgm:pt>
       </mc:Choice>
-      <mc:Fallback>
+      <mc:Fallback xmlns="">
         <dgm:pt modelId="{8675E681-D1E7-479B-A7B7-BE5042201E9A}">
           <dgm:prSet phldrT="[Testo]" custT="1"/>
           <dgm:spPr/>
@@ -6148,7 +6156,7 @@
               </a14:m>
               <a:r>
                 <a:rPr lang="en-US" sz="2000" dirty="0"/>
-                <a:t> = bid, meaning the tip paid by the user to gain priority</a:t>
+                <a:t> = bid (the tip paid by the user to gain priority)</a:t>
               </a:r>
               <a:endParaRPr lang="it-IT" sz="2000" dirty="0"/>
             </a:p>
@@ -6171,7 +6179,7 @@
               </a:r>
               <a:r>
                 <a:rPr lang="en-US" sz="2000" dirty="0"/>
-                <a:t> = bid, meaning the tip paid by the user to gain priority</a:t>
+                <a:t> = bid (the tip paid by the user to gain priority)</a:t>
               </a:r>
               <a:endParaRPr lang="it-IT" sz="2000" dirty="0"/>
             </a:p>
@@ -6201,8 +6209,8 @@
         </a:p>
       </dgm:t>
     </dgm:pt>
-    <mc:AlternateContent xmlns:mc="http://schemas.openxmlformats.org/markup-compatibility/2006">
-      <mc:Choice xmlns:a14="http://schemas.microsoft.com/office/drawing/2010/main" Requires="a14">
+    <mc:AlternateContent xmlns:mc="http://schemas.openxmlformats.org/markup-compatibility/2006" xmlns:a14="http://schemas.microsoft.com/office/drawing/2010/main">
+      <mc:Choice Requires="a14">
         <dgm:pt modelId="{7432C0E2-896C-4250-A5AE-24A5EB3A08DA}">
           <dgm:prSet phldrT="[Testo]" custT="1"/>
           <dgm:spPr/>
@@ -6252,7 +6260,7 @@
           </dgm:t>
         </dgm:pt>
       </mc:Choice>
-      <mc:Fallback>
+      <mc:Fallback xmlns="">
         <dgm:pt modelId="{7432C0E2-896C-4250-A5AE-24A5EB3A08DA}">
           <dgm:prSet phldrT="[Testo]" custT="1"/>
           <dgm:spPr/>
@@ -6512,7 +6520,7 @@
         <a:blipFill>
           <a:blip xmlns:r="http://schemas.openxmlformats.org/officeDocument/2006/relationships" r:embed="rId2"/>
           <a:stretch>
-            <a:fillRect t="-15000" b="-22000"/>
+            <a:fillRect/>
           </a:stretch>
         </a:blipFill>
       </dgm:spPr>
@@ -6755,16 +6763,15 @@
         </a:p>
       </dgm:t>
     </dgm:pt>
-    <dgm:pt modelId="{6D8D7C78-19EF-498D-A30F-08590BA1782C}">
+    <dgm:pt modelId="{289DE7AF-FBED-41BD-B1A0-45C1854170D4}">
       <dgm:prSet phldrT="[Testo]" phldr="0" custT="1"/>
       <dgm:spPr/>
       <dgm:t>
         <a:bodyPr/>
         <a:lstStyle/>
         <a:p>
-          <a:pPr rtl="0"/>
           <a:r>
-            <a:rPr lang="en-GB" sz="2000" kern="1200" noProof="1">
+            <a:rPr lang="en-US" sz="2400" kern="1200" dirty="0">
               <a:solidFill>
                 <a:prstClr val="black">
                   <a:hueOff val="0"/>
@@ -6777,106 +6784,20 @@
               <a:ea typeface="+mn-ea"/>
               <a:cs typeface="+mn-cs"/>
             </a:rPr>
-            <a:t>One of the protocols discussed is Themis: each node submits its own local transaction ordering, and a leader attempts to construct a global ordering verified through cryptographic proofs.</a:t>
-          </a:r>
-        </a:p>
-      </dgm:t>
-    </dgm:pt>
-    <dgm:pt modelId="{203A4AE1-2F2C-4056-B5D8-A46B37653A87}" type="parTrans" cxnId="{21D141EA-7CEE-4B9B-9005-7C7CC321216C}">
-      <dgm:prSet/>
-      <dgm:spPr/>
-      <dgm:t>
-        <a:bodyPr/>
-        <a:lstStyle/>
-        <a:p>
-          <a:endParaRPr lang="it-IT"/>
-        </a:p>
-      </dgm:t>
-    </dgm:pt>
-    <dgm:pt modelId="{AF94704D-78FF-4B9B-966F-C00133063768}" type="sibTrans" cxnId="{21D141EA-7CEE-4B9B-9005-7C7CC321216C}">
-      <dgm:prSet/>
-      <dgm:spPr/>
-      <dgm:t>
-        <a:bodyPr/>
-        <a:lstStyle/>
-        <a:p>
-          <a:endParaRPr lang="it-IT"/>
-        </a:p>
-      </dgm:t>
-    </dgm:pt>
-    <dgm:pt modelId="{C14BCB6A-D610-47C8-9F87-EB6B61E11563}">
-      <dgm:prSet phldrT="[Testo]" phldr="0" custT="1"/>
-      <dgm:spPr/>
-      <dgm:t>
-        <a:bodyPr/>
-        <a:lstStyle/>
-        <a:p>
-          <a:pPr marL="0" lvl="0" indent="0" algn="l" defTabSz="889000" rtl="0">
-            <a:lnSpc>
-              <a:spcPct val="90000"/>
-            </a:lnSpc>
-            <a:spcBef>
-              <a:spcPct val="0"/>
-            </a:spcBef>
-            <a:spcAft>
-              <a:spcPct val="35000"/>
-            </a:spcAft>
-            <a:buNone/>
-          </a:pPr>
-          <a:r>
-            <a:rPr lang="en-GB" sz="2000" kern="1200" noProof="1">
-              <a:solidFill>
-                <a:prstClr val="black">
-                  <a:hueOff val="0"/>
-                  <a:satOff val="0"/>
-                  <a:lumOff val="0"/>
-                  <a:alphaOff val="0"/>
-                </a:prstClr>
-              </a:solidFill>
-              <a:latin typeface="Century Gothic" panose="020B0502020202020204"/>
-              <a:ea typeface="+mn-ea"/>
-              <a:cs typeface="+mn-cs"/>
-            </a:rPr>
-            <a:t>Another approach is Wendy, which uses synchronized timestamps to order transactions. </a:t>
-          </a:r>
-        </a:p>
-      </dgm:t>
-    </dgm:pt>
-    <dgm:pt modelId="{24525818-68C5-418D-9C71-065A336570B7}" type="parTrans" cxnId="{0CA66762-04B2-4ABA-BE19-37C73BA973E3}">
-      <dgm:prSet/>
-      <dgm:spPr/>
-      <dgm:t>
-        <a:bodyPr/>
-        <a:lstStyle/>
-        <a:p>
-          <a:endParaRPr lang="it-IT"/>
-        </a:p>
-      </dgm:t>
-    </dgm:pt>
-    <dgm:pt modelId="{DFD1B4E4-0DAB-4443-9B8B-12EF480601D0}" type="sibTrans" cxnId="{0CA66762-04B2-4ABA-BE19-37C73BA973E3}">
-      <dgm:prSet/>
-      <dgm:spPr/>
-      <dgm:t>
-        <a:bodyPr/>
-        <a:lstStyle/>
-        <a:p>
-          <a:endParaRPr lang="it-IT"/>
-        </a:p>
-      </dgm:t>
-    </dgm:pt>
-    <dgm:pt modelId="{289DE7AF-FBED-41BD-B1A0-45C1854170D4}">
-      <dgm:prSet phldrT="[Testo]" phldr="0" custT="1"/>
-      <dgm:spPr/>
-      <dgm:t>
-        <a:bodyPr/>
-        <a:lstStyle/>
-        <a:p>
-          <a:r>
-            <a:rPr lang="en-US" sz="2000" dirty="0"/>
             <a:t>Several nodes collaborate to decide transaction ordering instead of relying on a single operator. </a:t>
           </a:r>
-          <a:endParaRPr lang="en-GB" sz="2000" b="0" noProof="1">
-            <a:latin typeface="Aptos"/>
+          <a:endParaRPr lang="en-GB" sz="2400" kern="1200" noProof="1">
+            <a:solidFill>
+              <a:prstClr val="black">
+                <a:hueOff val="0"/>
+                <a:satOff val="0"/>
+                <a:lumOff val="0"/>
+                <a:alphaOff val="0"/>
+              </a:prstClr>
+            </a:solidFill>
+            <a:latin typeface="Century Gothic" panose="020B0502020202020204"/>
+            <a:ea typeface="+mn-ea"/>
+            <a:cs typeface="+mn-cs"/>
           </a:endParaRPr>
         </a:p>
       </dgm:t>
@@ -6893,6 +6814,114 @@
       </dgm:t>
     </dgm:pt>
     <dgm:pt modelId="{CA25B09A-0357-46B2-9BE5-3559EC73F275}" type="sibTrans" cxnId="{DB3CCAF7-ABAC-4FEA-B4E3-FC7ADF875398}">
+      <dgm:prSet/>
+      <dgm:spPr/>
+      <dgm:t>
+        <a:bodyPr/>
+        <a:lstStyle/>
+        <a:p>
+          <a:endParaRPr lang="it-IT"/>
+        </a:p>
+      </dgm:t>
+    </dgm:pt>
+    <dgm:pt modelId="{59BFAF94-5105-4C3C-B903-1C65A4037263}">
+      <dgm:prSet phldrT="[Testo]" phldr="0" custT="1"/>
+      <dgm:spPr/>
+      <dgm:t>
+        <a:bodyPr/>
+        <a:lstStyle/>
+        <a:p>
+          <a:r>
+            <a:rPr lang="en-GB" sz="2400" kern="1200" noProof="1">
+              <a:solidFill>
+                <a:prstClr val="black">
+                  <a:hueOff val="0"/>
+                  <a:satOff val="0"/>
+                  <a:lumOff val="0"/>
+                  <a:alphaOff val="0"/>
+                </a:prstClr>
+              </a:solidFill>
+              <a:latin typeface="Century Gothic" panose="020B0502020202020204"/>
+              <a:ea typeface="+mn-ea"/>
+              <a:cs typeface="+mn-cs"/>
+            </a:rPr>
+            <a:t>Themis and Wendy: temporary leaders or synchronized timestamp across nodes</a:t>
+          </a:r>
+        </a:p>
+      </dgm:t>
+    </dgm:pt>
+    <dgm:pt modelId="{BB1F17F3-DB5B-4DA6-AFDE-5BC422B78BEF}" type="parTrans" cxnId="{B4C2A61E-4D6B-4B6F-91B8-685C7A8BC877}">
+      <dgm:prSet/>
+      <dgm:spPr/>
+      <dgm:t>
+        <a:bodyPr/>
+        <a:lstStyle/>
+        <a:p>
+          <a:endParaRPr lang="it-IT"/>
+        </a:p>
+      </dgm:t>
+    </dgm:pt>
+    <dgm:pt modelId="{B47ED674-477C-451D-A063-8C811D4455E6}" type="sibTrans" cxnId="{B4C2A61E-4D6B-4B6F-91B8-685C7A8BC877}">
+      <dgm:prSet/>
+      <dgm:spPr/>
+      <dgm:t>
+        <a:bodyPr/>
+        <a:lstStyle/>
+        <a:p>
+          <a:endParaRPr lang="it-IT"/>
+        </a:p>
+      </dgm:t>
+    </dgm:pt>
+    <dgm:pt modelId="{2394B2E9-00E8-4656-8505-BA5DC76EBF4B}">
+      <dgm:prSet phldrT="[Testo]" phldr="0" custT="1"/>
+      <dgm:spPr/>
+      <dgm:t>
+        <a:bodyPr/>
+        <a:lstStyle/>
+        <a:p>
+          <a:pPr marL="0" lvl="0" indent="0" algn="l" defTabSz="1066800">
+            <a:lnSpc>
+              <a:spcPct val="90000"/>
+            </a:lnSpc>
+            <a:spcBef>
+              <a:spcPct val="0"/>
+            </a:spcBef>
+            <a:spcAft>
+              <a:spcPct val="35000"/>
+            </a:spcAft>
+            <a:buNone/>
+          </a:pPr>
+          <a:r>
+            <a:rPr lang="en-GB" sz="2400" kern="1200" noProof="1">
+              <a:solidFill>
+                <a:prstClr val="black">
+                  <a:hueOff val="0"/>
+                  <a:satOff val="0"/>
+                  <a:lumOff val="0"/>
+                  <a:alphaOff val="0"/>
+                </a:prstClr>
+              </a:solidFill>
+              <a:latin typeface="Century Gothic" panose="020B0502020202020204"/>
+              <a:ea typeface="+mn-ea"/>
+              <a:cs typeface="+mn-cs"/>
+            </a:rPr>
+            <a:t>Require significant coordination and increase complexity and network overhead.</a:t>
+          </a:r>
+        </a:p>
+      </dgm:t>
+    </dgm:pt>
+    <dgm:pt modelId="{4F7161A5-8329-4579-9A68-9247C2A3DD0E}" type="parTrans" cxnId="{71E0E84F-E1BD-4A29-9819-F05FAB080F11}">
+      <dgm:prSet/>
+      <dgm:spPr/>
+      <dgm:t>
+        <a:bodyPr/>
+        <a:lstStyle/>
+        <a:p>
+          <a:endParaRPr lang="it-IT"/>
+        </a:p>
+      </dgm:t>
+    </dgm:pt>
+    <dgm:pt modelId="{4ADF4416-D86F-4C59-A771-FF8D2258E569}" type="sibTrans" cxnId="{71E0E84F-E1BD-4A29-9819-F05FAB080F11}">
       <dgm:prSet/>
       <dgm:spPr/>
       <dgm:t>
@@ -6929,59 +6958,59 @@
       <dgm:prSet presAssocID="{289DE7AF-FBED-41BD-B1A0-45C1854170D4}" presName="vert1" presStyleCnt="0"/>
       <dgm:spPr/>
     </dgm:pt>
-    <dgm:pt modelId="{C123A4A3-C6B0-441F-8EF4-E9E43EBD83E7}" type="pres">
-      <dgm:prSet presAssocID="{6D8D7C78-19EF-498D-A30F-08590BA1782C}" presName="thickLine" presStyleLbl="alignNode1" presStyleIdx="1" presStyleCnt="3"/>
+    <dgm:pt modelId="{66A3C529-44F3-4C22-9A20-D7276C7CAC47}" type="pres">
+      <dgm:prSet presAssocID="{59BFAF94-5105-4C3C-B903-1C65A4037263}" presName="thickLine" presStyleLbl="alignNode1" presStyleIdx="1" presStyleCnt="3"/>
       <dgm:spPr/>
     </dgm:pt>
-    <dgm:pt modelId="{84EA240E-587B-45AC-AD81-B0A158C3AE1A}" type="pres">
-      <dgm:prSet presAssocID="{6D8D7C78-19EF-498D-A30F-08590BA1782C}" presName="horz1" presStyleCnt="0"/>
+    <dgm:pt modelId="{DC231F03-E1E2-4101-863B-2AA65953B7C7}" type="pres">
+      <dgm:prSet presAssocID="{59BFAF94-5105-4C3C-B903-1C65A4037263}" presName="horz1" presStyleCnt="0"/>
       <dgm:spPr/>
     </dgm:pt>
-    <dgm:pt modelId="{80FB8A52-7AD5-4C62-8029-C035067A48D9}" type="pres">
-      <dgm:prSet presAssocID="{6D8D7C78-19EF-498D-A30F-08590BA1782C}" presName="tx1" presStyleLbl="revTx" presStyleIdx="1" presStyleCnt="3"/>
+    <dgm:pt modelId="{D43E5BD0-52EC-4245-9D86-6CD69D3AEED0}" type="pres">
+      <dgm:prSet presAssocID="{59BFAF94-5105-4C3C-B903-1C65A4037263}" presName="tx1" presStyleLbl="revTx" presStyleIdx="1" presStyleCnt="3"/>
       <dgm:spPr/>
     </dgm:pt>
-    <dgm:pt modelId="{4A2C1789-E9CB-4D8F-AAFA-39741AD915CD}" type="pres">
-      <dgm:prSet presAssocID="{6D8D7C78-19EF-498D-A30F-08590BA1782C}" presName="vert1" presStyleCnt="0"/>
+    <dgm:pt modelId="{DDDD9F5C-2E82-46C2-942D-439C114B6EF4}" type="pres">
+      <dgm:prSet presAssocID="{59BFAF94-5105-4C3C-B903-1C65A4037263}" presName="vert1" presStyleCnt="0"/>
       <dgm:spPr/>
     </dgm:pt>
-    <dgm:pt modelId="{8F57034E-4A7F-429F-B43F-3EF04489A479}" type="pres">
-      <dgm:prSet presAssocID="{C14BCB6A-D610-47C8-9F87-EB6B61E11563}" presName="thickLine" presStyleLbl="alignNode1" presStyleIdx="2" presStyleCnt="3"/>
+    <dgm:pt modelId="{0748698C-D25C-4BF9-844E-D13628BC12BB}" type="pres">
+      <dgm:prSet presAssocID="{2394B2E9-00E8-4656-8505-BA5DC76EBF4B}" presName="thickLine" presStyleLbl="alignNode1" presStyleIdx="2" presStyleCnt="3"/>
       <dgm:spPr/>
     </dgm:pt>
-    <dgm:pt modelId="{ABE06A4B-648F-492D-969E-E653AA461437}" type="pres">
-      <dgm:prSet presAssocID="{C14BCB6A-D610-47C8-9F87-EB6B61E11563}" presName="horz1" presStyleCnt="0"/>
+    <dgm:pt modelId="{1CC20420-9656-4F78-A2C7-A1B15C42EF49}" type="pres">
+      <dgm:prSet presAssocID="{2394B2E9-00E8-4656-8505-BA5DC76EBF4B}" presName="horz1" presStyleCnt="0"/>
       <dgm:spPr/>
     </dgm:pt>
-    <dgm:pt modelId="{5E03B85D-0B36-4138-A85C-C849C3B245D8}" type="pres">
-      <dgm:prSet presAssocID="{C14BCB6A-D610-47C8-9F87-EB6B61E11563}" presName="tx1" presStyleLbl="revTx" presStyleIdx="2" presStyleCnt="3"/>
+    <dgm:pt modelId="{A123DFA8-A85A-4398-B7F1-3218A71E99ED}" type="pres">
+      <dgm:prSet presAssocID="{2394B2E9-00E8-4656-8505-BA5DC76EBF4B}" presName="tx1" presStyleLbl="revTx" presStyleIdx="2" presStyleCnt="3"/>
       <dgm:spPr/>
     </dgm:pt>
-    <dgm:pt modelId="{B461D071-076B-4AEB-80D4-222FA1BF30B6}" type="pres">
-      <dgm:prSet presAssocID="{C14BCB6A-D610-47C8-9F87-EB6B61E11563}" presName="vert1" presStyleCnt="0"/>
+    <dgm:pt modelId="{68778E28-D725-49E9-9E0B-B7D19FE2444F}" type="pres">
+      <dgm:prSet presAssocID="{2394B2E9-00E8-4656-8505-BA5DC76EBF4B}" presName="vert1" presStyleCnt="0"/>
       <dgm:spPr/>
     </dgm:pt>
   </dgm:ptLst>
   <dgm:cxnLst>
-    <dgm:cxn modelId="{7CB94620-F193-4B25-AB8F-116E00E20DE5}" type="presOf" srcId="{6D8D7C78-19EF-498D-A30F-08590BA1782C}" destId="{80FB8A52-7AD5-4C62-8029-C035067A48D9}" srcOrd="0" destOrd="0" presId="urn:microsoft.com/office/officeart/2008/layout/LinedList"/>
+    <dgm:cxn modelId="{B4C2A61E-4D6B-4B6F-91B8-685C7A8BC877}" srcId="{E69D3792-D02C-4300-8235-67DB909F6BE9}" destId="{59BFAF94-5105-4C3C-B903-1C65A4037263}" srcOrd="1" destOrd="0" parTransId="{BB1F17F3-DB5B-4DA6-AFDE-5BC422B78BEF}" sibTransId="{B47ED674-477C-451D-A063-8C811D4455E6}"/>
     <dgm:cxn modelId="{5D092B27-6511-4153-9DA7-C6C8D6D45369}" type="presOf" srcId="{E69D3792-D02C-4300-8235-67DB909F6BE9}" destId="{E5A8A804-9124-457C-A172-A9ED38EBD4A4}" srcOrd="0" destOrd="0" presId="urn:microsoft.com/office/officeart/2008/layout/LinedList"/>
-    <dgm:cxn modelId="{0CA66762-04B2-4ABA-BE19-37C73BA973E3}" srcId="{E69D3792-D02C-4300-8235-67DB909F6BE9}" destId="{C14BCB6A-D610-47C8-9F87-EB6B61E11563}" srcOrd="2" destOrd="0" parTransId="{24525818-68C5-418D-9C71-065A336570B7}" sibTransId="{DFD1B4E4-0DAB-4443-9B8B-12EF480601D0}"/>
     <dgm:cxn modelId="{43227746-07AE-46D3-AB0B-97012B946F67}" type="presOf" srcId="{289DE7AF-FBED-41BD-B1A0-45C1854170D4}" destId="{BB67C430-7DDE-4D20-9B9D-994679C40CE3}" srcOrd="0" destOrd="0" presId="urn:microsoft.com/office/officeart/2008/layout/LinedList"/>
-    <dgm:cxn modelId="{66A5D194-E5C6-4966-8EBF-E0CB348B3203}" type="presOf" srcId="{C14BCB6A-D610-47C8-9F87-EB6B61E11563}" destId="{5E03B85D-0B36-4138-A85C-C849C3B245D8}" srcOrd="0" destOrd="0" presId="urn:microsoft.com/office/officeart/2008/layout/LinedList"/>
-    <dgm:cxn modelId="{21D141EA-7CEE-4B9B-9005-7C7CC321216C}" srcId="{E69D3792-D02C-4300-8235-67DB909F6BE9}" destId="{6D8D7C78-19EF-498D-A30F-08590BA1782C}" srcOrd="1" destOrd="0" parTransId="{203A4AE1-2F2C-4056-B5D8-A46B37653A87}" sibTransId="{AF94704D-78FF-4B9B-966F-C00133063768}"/>
+    <dgm:cxn modelId="{71E0E84F-E1BD-4A29-9819-F05FAB080F11}" srcId="{E69D3792-D02C-4300-8235-67DB909F6BE9}" destId="{2394B2E9-00E8-4656-8505-BA5DC76EBF4B}" srcOrd="2" destOrd="0" parTransId="{4F7161A5-8329-4579-9A68-9247C2A3DD0E}" sibTransId="{4ADF4416-D86F-4C59-A771-FF8D2258E569}"/>
+    <dgm:cxn modelId="{6D4AB6C2-5373-460F-ABF6-164E415CA711}" type="presOf" srcId="{2394B2E9-00E8-4656-8505-BA5DC76EBF4B}" destId="{A123DFA8-A85A-4398-B7F1-3218A71E99ED}" srcOrd="0" destOrd="0" presId="urn:microsoft.com/office/officeart/2008/layout/LinedList"/>
     <dgm:cxn modelId="{DB3CCAF7-ABAC-4FEA-B4E3-FC7ADF875398}" srcId="{E69D3792-D02C-4300-8235-67DB909F6BE9}" destId="{289DE7AF-FBED-41BD-B1A0-45C1854170D4}" srcOrd="0" destOrd="0" parTransId="{CF0092C5-741E-4F78-8CE1-893EA77A4460}" sibTransId="{CA25B09A-0357-46B2-9BE5-3559EC73F275}"/>
+    <dgm:cxn modelId="{8AD7EFF8-3E38-4035-BEF1-6D5232EC33FD}" type="presOf" srcId="{59BFAF94-5105-4C3C-B903-1C65A4037263}" destId="{D43E5BD0-52EC-4245-9D86-6CD69D3AEED0}" srcOrd="0" destOrd="0" presId="urn:microsoft.com/office/officeart/2008/layout/LinedList"/>
     <dgm:cxn modelId="{40C88E08-23CF-4EFC-BC3A-87FDAFA4EBFF}" type="presParOf" srcId="{E5A8A804-9124-457C-A172-A9ED38EBD4A4}" destId="{C02DFA33-96C5-4ADF-AE6A-35559B388AE3}" srcOrd="0" destOrd="0" presId="urn:microsoft.com/office/officeart/2008/layout/LinedList"/>
     <dgm:cxn modelId="{58867C82-7E2B-41FC-BBA6-F5EC0376CF47}" type="presParOf" srcId="{E5A8A804-9124-457C-A172-A9ED38EBD4A4}" destId="{D97865D7-B866-4D00-AF6E-86BE4A75A550}" srcOrd="1" destOrd="0" presId="urn:microsoft.com/office/officeart/2008/layout/LinedList"/>
     <dgm:cxn modelId="{41C9226F-613B-4D2D-89A7-C471D0D4213E}" type="presParOf" srcId="{D97865D7-B866-4D00-AF6E-86BE4A75A550}" destId="{BB67C430-7DDE-4D20-9B9D-994679C40CE3}" srcOrd="0" destOrd="0" presId="urn:microsoft.com/office/officeart/2008/layout/LinedList"/>
     <dgm:cxn modelId="{3FAEAB4A-067D-456B-B89F-67D553676295}" type="presParOf" srcId="{D97865D7-B866-4D00-AF6E-86BE4A75A550}" destId="{76460AEC-325F-4BE6-B1A1-2C5BC67D6E77}" srcOrd="1" destOrd="0" presId="urn:microsoft.com/office/officeart/2008/layout/LinedList"/>
-    <dgm:cxn modelId="{2462C1F6-FAD5-4106-97FD-17B4C0F47817}" type="presParOf" srcId="{E5A8A804-9124-457C-A172-A9ED38EBD4A4}" destId="{C123A4A3-C6B0-441F-8EF4-E9E43EBD83E7}" srcOrd="2" destOrd="0" presId="urn:microsoft.com/office/officeart/2008/layout/LinedList"/>
-    <dgm:cxn modelId="{196FD900-D268-40DA-94FF-C9DF244ED374}" type="presParOf" srcId="{E5A8A804-9124-457C-A172-A9ED38EBD4A4}" destId="{84EA240E-587B-45AC-AD81-B0A158C3AE1A}" srcOrd="3" destOrd="0" presId="urn:microsoft.com/office/officeart/2008/layout/LinedList"/>
-    <dgm:cxn modelId="{15564A92-ED42-4246-BB9A-98F3F2F3982B}" type="presParOf" srcId="{84EA240E-587B-45AC-AD81-B0A158C3AE1A}" destId="{80FB8A52-7AD5-4C62-8029-C035067A48D9}" srcOrd="0" destOrd="0" presId="urn:microsoft.com/office/officeart/2008/layout/LinedList"/>
-    <dgm:cxn modelId="{04583315-EEC1-41B0-AA77-18F916E83780}" type="presParOf" srcId="{84EA240E-587B-45AC-AD81-B0A158C3AE1A}" destId="{4A2C1789-E9CB-4D8F-AAFA-39741AD915CD}" srcOrd="1" destOrd="0" presId="urn:microsoft.com/office/officeart/2008/layout/LinedList"/>
-    <dgm:cxn modelId="{DD6D4BAA-FB5C-4A14-A7E5-07AE5E0F363B}" type="presParOf" srcId="{E5A8A804-9124-457C-A172-A9ED38EBD4A4}" destId="{8F57034E-4A7F-429F-B43F-3EF04489A479}" srcOrd="4" destOrd="0" presId="urn:microsoft.com/office/officeart/2008/layout/LinedList"/>
-    <dgm:cxn modelId="{E8E3EA1B-4869-4D6D-A663-2149A42E99A6}" type="presParOf" srcId="{E5A8A804-9124-457C-A172-A9ED38EBD4A4}" destId="{ABE06A4B-648F-492D-969E-E653AA461437}" srcOrd="5" destOrd="0" presId="urn:microsoft.com/office/officeart/2008/layout/LinedList"/>
-    <dgm:cxn modelId="{76289D12-DF80-4D57-B1CB-8407B092032C}" type="presParOf" srcId="{ABE06A4B-648F-492D-969E-E653AA461437}" destId="{5E03B85D-0B36-4138-A85C-C849C3B245D8}" srcOrd="0" destOrd="0" presId="urn:microsoft.com/office/officeart/2008/layout/LinedList"/>
-    <dgm:cxn modelId="{240746DA-7DC5-4A9A-88EC-92503BCA0E7A}" type="presParOf" srcId="{ABE06A4B-648F-492D-969E-E653AA461437}" destId="{B461D071-076B-4AEB-80D4-222FA1BF30B6}" srcOrd="1" destOrd="0" presId="urn:microsoft.com/office/officeart/2008/layout/LinedList"/>
+    <dgm:cxn modelId="{EC182638-E792-46A2-99AC-13A9C41358AD}" type="presParOf" srcId="{E5A8A804-9124-457C-A172-A9ED38EBD4A4}" destId="{66A3C529-44F3-4C22-9A20-D7276C7CAC47}" srcOrd="2" destOrd="0" presId="urn:microsoft.com/office/officeart/2008/layout/LinedList"/>
+    <dgm:cxn modelId="{EDBEE1E3-BF83-4861-A900-3F6BA9306F72}" type="presParOf" srcId="{E5A8A804-9124-457C-A172-A9ED38EBD4A4}" destId="{DC231F03-E1E2-4101-863B-2AA65953B7C7}" srcOrd="3" destOrd="0" presId="urn:microsoft.com/office/officeart/2008/layout/LinedList"/>
+    <dgm:cxn modelId="{F885F9CB-DFF0-44FB-B853-D4E1700F3898}" type="presParOf" srcId="{DC231F03-E1E2-4101-863B-2AA65953B7C7}" destId="{D43E5BD0-52EC-4245-9D86-6CD69D3AEED0}" srcOrd="0" destOrd="0" presId="urn:microsoft.com/office/officeart/2008/layout/LinedList"/>
+    <dgm:cxn modelId="{50C617C6-4B19-4CB2-8EE2-18ABA398116E}" type="presParOf" srcId="{DC231F03-E1E2-4101-863B-2AA65953B7C7}" destId="{DDDD9F5C-2E82-46C2-942D-439C114B6EF4}" srcOrd="1" destOrd="0" presId="urn:microsoft.com/office/officeart/2008/layout/LinedList"/>
+    <dgm:cxn modelId="{7A69CD79-A781-4E15-B8F8-FE66B99E7BB4}" type="presParOf" srcId="{E5A8A804-9124-457C-A172-A9ED38EBD4A4}" destId="{0748698C-D25C-4BF9-844E-D13628BC12BB}" srcOrd="4" destOrd="0" presId="urn:microsoft.com/office/officeart/2008/layout/LinedList"/>
+    <dgm:cxn modelId="{118D566B-84A9-4F94-BEB3-BFB4A3290786}" type="presParOf" srcId="{E5A8A804-9124-457C-A172-A9ED38EBD4A4}" destId="{1CC20420-9656-4F78-A2C7-A1B15C42EF49}" srcOrd="5" destOrd="0" presId="urn:microsoft.com/office/officeart/2008/layout/LinedList"/>
+    <dgm:cxn modelId="{425F4CAE-13A7-4CE0-810C-61A94B424317}" type="presParOf" srcId="{1CC20420-9656-4F78-A2C7-A1B15C42EF49}" destId="{A123DFA8-A85A-4398-B7F1-3218A71E99ED}" srcOrd="0" destOrd="0" presId="urn:microsoft.com/office/officeart/2008/layout/LinedList"/>
+    <dgm:cxn modelId="{C36B5FDF-DFA3-4A7F-9988-C625A339E472}" type="presParOf" srcId="{1CC20420-9656-4F78-A2C7-A1B15C42EF49}" destId="{68778E28-D725-49E9-9E0B-B7D19FE2444F}" srcOrd="1" destOrd="0" presId="urn:microsoft.com/office/officeart/2008/layout/LinedList"/>
   </dgm:cxnLst>
   <dgm:bg/>
   <dgm:whole/>
@@ -7008,17 +7037,17 @@
       </dgm:t>
     </dgm:pt>
     <dgm:pt modelId="{058AD00E-BAC8-4CBB-BAD5-440E22A73BA1}">
-      <dgm:prSet phldrT="[Testo]"/>
+      <dgm:prSet phldrT="[Testo]" custT="1"/>
       <dgm:spPr/>
       <dgm:t>
         <a:bodyPr/>
         <a:lstStyle/>
         <a:p>
           <a:r>
-            <a:rPr lang="en-US" dirty="0"/>
+            <a:rPr lang="en-US" sz="2400" dirty="0"/>
             <a:t>Threshold Encryption</a:t>
           </a:r>
-          <a:endParaRPr lang="it-IT" dirty="0"/>
+          <a:endParaRPr lang="it-IT" sz="2400" dirty="0"/>
         </a:p>
       </dgm:t>
     </dgm:pt>
@@ -7119,17 +7148,17 @@
       </dgm:t>
     </dgm:pt>
     <dgm:pt modelId="{CE79C382-58E9-4FF7-A403-7AE865F3FD19}">
-      <dgm:prSet phldrT="[Testo]"/>
+      <dgm:prSet phldrT="[Testo]" custT="1"/>
       <dgm:spPr/>
       <dgm:t>
         <a:bodyPr/>
         <a:lstStyle/>
         <a:p>
           <a:r>
-            <a:rPr lang="en-US" dirty="0"/>
+            <a:rPr lang="en-US" sz="2400" dirty="0"/>
             <a:t>Delay Encryption</a:t>
           </a:r>
-          <a:endParaRPr lang="it-IT" dirty="0"/>
+          <a:endParaRPr lang="it-IT" sz="2400" dirty="0"/>
         </a:p>
       </dgm:t>
     </dgm:pt>
@@ -7230,17 +7259,17 @@
       </dgm:t>
     </dgm:pt>
     <dgm:pt modelId="{F68C1405-75B8-45E2-95BD-F676C6BEACFC}">
-      <dgm:prSet phldrT="[Testo]"/>
+      <dgm:prSet phldrT="[Testo]" custT="1"/>
       <dgm:spPr/>
       <dgm:t>
         <a:bodyPr/>
         <a:lstStyle/>
         <a:p>
           <a:r>
-            <a:rPr lang="en-US" dirty="0"/>
+            <a:rPr lang="en-US" sz="2400" dirty="0"/>
             <a:t>Trusted Execution Environments</a:t>
           </a:r>
-          <a:endParaRPr lang="it-IT" dirty="0"/>
+          <a:endParaRPr lang="it-IT" sz="2400" dirty="0"/>
         </a:p>
       </dgm:t>
     </dgm:pt>
@@ -7355,7 +7384,7 @@
       <dgm:spPr/>
     </dgm:pt>
     <dgm:pt modelId="{28AD86E7-8144-4D70-9CD4-38A296CE6AAC}" type="pres">
-      <dgm:prSet presAssocID="{058AD00E-BAC8-4CBB-BAD5-440E22A73BA1}" presName="parentText" presStyleLbl="node1" presStyleIdx="0" presStyleCnt="3">
+      <dgm:prSet presAssocID="{058AD00E-BAC8-4CBB-BAD5-440E22A73BA1}" presName="parentText" presStyleLbl="node1" presStyleIdx="0" presStyleCnt="3" custScaleX="60315">
         <dgm:presLayoutVars>
           <dgm:chMax val="1"/>
           <dgm:bulletEnabled val="1"/>
@@ -7380,7 +7409,7 @@
       <dgm:spPr/>
     </dgm:pt>
     <dgm:pt modelId="{DE2088EE-38A1-4533-883F-078B177E039D}" type="pres">
-      <dgm:prSet presAssocID="{CE79C382-58E9-4FF7-A403-7AE865F3FD19}" presName="parentText" presStyleLbl="node1" presStyleIdx="1" presStyleCnt="3">
+      <dgm:prSet presAssocID="{CE79C382-58E9-4FF7-A403-7AE865F3FD19}" presName="parentText" presStyleLbl="node1" presStyleIdx="1" presStyleCnt="3" custScaleX="61356">
         <dgm:presLayoutVars>
           <dgm:chMax val="1"/>
           <dgm:bulletEnabled val="1"/>
@@ -7405,7 +7434,7 @@
       <dgm:spPr/>
     </dgm:pt>
     <dgm:pt modelId="{7A93E996-01DC-4918-816B-EB11EDF9F088}" type="pres">
-      <dgm:prSet presAssocID="{F68C1405-75B8-45E2-95BD-F676C6BEACFC}" presName="parentText" presStyleLbl="node1" presStyleIdx="2" presStyleCnt="3">
+      <dgm:prSet presAssocID="{F68C1405-75B8-45E2-95BD-F676C6BEACFC}" presName="parentText" presStyleLbl="node1" presStyleIdx="2" presStyleCnt="3" custScaleX="62214">
         <dgm:presLayoutVars>
           <dgm:chMax val="1"/>
           <dgm:bulletEnabled val="1"/>
@@ -7842,27 +7871,11 @@
           </a:r>
           <a:r>
             <a:rPr lang="it-IT" kern="1200" dirty="0"/>
-            <a:t> the </a:t>
+            <a:t> the power of </a:t>
           </a:r>
           <a:r>
             <a:rPr lang="it-IT" kern="1200" dirty="0" err="1"/>
-            <a:t>validators</a:t>
-          </a:r>
-          <a:r>
-            <a:rPr lang="it-IT" kern="1200" dirty="0"/>
-            <a:t>’ </a:t>
-          </a:r>
-          <a:r>
-            <a:rPr lang="it-IT" kern="1200" dirty="0" err="1"/>
-            <a:t>direct</a:t>
-          </a:r>
-          <a:r>
-            <a:rPr lang="it-IT" kern="1200" dirty="0"/>
-            <a:t> power to </a:t>
-          </a:r>
-          <a:r>
-            <a:rPr lang="it-IT" kern="1200" dirty="0" err="1"/>
-            <a:t>manipulate</a:t>
+            <a:t>individual</a:t>
           </a:r>
           <a:r>
             <a:rPr lang="it-IT" kern="1200" dirty="0"/>
@@ -7870,7 +7883,7 @@
           </a:r>
           <a:r>
             <a:rPr lang="it-IT" kern="1200" dirty="0" err="1"/>
-            <a:t>transactions</a:t>
+            <a:t>validators</a:t>
           </a:r>
           <a:endParaRPr lang="en-US" b="0" i="0" u="none" strike="noStrike" kern="1200" baseline="0" dirty="0">
             <a:latin typeface="Aptos"/>
@@ -7915,28 +7928,36 @@
             </a:lnSpc>
           </a:pPr>
           <a:r>
+            <a:rPr lang="it-IT" kern="1200" dirty="0" err="1"/>
+            <a:t>Introduces</a:t>
+          </a:r>
+          <a:r>
             <a:rPr lang="it-IT" kern="1200" dirty="0"/>
-            <a:t>The </a:t>
+            <a:t> new </a:t>
           </a:r>
           <a:r>
             <a:rPr lang="it-IT" kern="1200" dirty="0" err="1"/>
-            <a:t>problem</a:t>
+            <a:t>centralization</a:t>
           </a:r>
           <a:r>
             <a:rPr lang="it-IT" kern="1200" dirty="0"/>
-            <a:t> shifts from </a:t>
+            <a:t> risks </a:t>
           </a:r>
           <a:r>
             <a:rPr lang="it-IT" kern="1200" dirty="0" err="1"/>
-            <a:t>validators</a:t>
+            <a:t>around</a:t>
           </a:r>
           <a:r>
             <a:rPr lang="it-IT" kern="1200" dirty="0"/>
-            <a:t> to </a:t>
+            <a:t> </a:t>
           </a:r>
           <a:r>
             <a:rPr lang="it-IT" kern="1200" dirty="0" err="1"/>
             <a:t>relays</a:t>
+          </a:r>
+          <a:r>
+            <a:rPr lang="it-IT" kern="1200" dirty="0"/>
+            <a:t> and builders</a:t>
           </a:r>
           <a:endParaRPr lang="en-US" b="0" i="0" u="none" strike="noStrike" kern="1200" baseline="0" dirty="0">
             <a:latin typeface="Aptos"/>
@@ -8250,12 +8271,12 @@
         <a:fontRef idx="minor"/>
       </dsp:style>
       <dsp:txBody>
-        <a:bodyPr spcFirstLastPara="0" vert="horz" wrap="square" lIns="91440" tIns="91440" rIns="91440" bIns="91440" numCol="1" spcCol="1270" anchor="t" anchorCtr="0">
+        <a:bodyPr spcFirstLastPara="0" vert="horz" wrap="square" lIns="76200" tIns="76200" rIns="76200" bIns="76200" numCol="1" spcCol="1270" anchor="t" anchorCtr="0">
           <a:noAutofit/>
         </a:bodyPr>
         <a:lstStyle/>
         <a:p>
-          <a:pPr marL="0" lvl="0" indent="0" algn="l" defTabSz="1066800">
+          <a:pPr marL="0" lvl="0" indent="0" algn="l" defTabSz="889000">
             <a:lnSpc>
               <a:spcPct val="90000"/>
             </a:lnSpc>
@@ -8268,12 +8289,20 @@
             <a:buNone/>
           </a:pPr>
           <a:r>
-            <a:rPr lang="en-US" sz="2400" b="1" kern="1200" dirty="0"/>
-            <a:t>Preventing or reducing MEV</a:t>
+            <a:rPr lang="en-US" sz="2000" b="1" kern="1200" dirty="0"/>
+            <a:t>Prevention/Reduction</a:t>
           </a:r>
           <a:r>
-            <a:rPr lang="en-US" sz="2400" kern="1200" dirty="0"/>
-            <a:t>: limit opportunities for MEV extraction</a:t>
+            <a:rPr lang="en-US" sz="2000" kern="1200" dirty="0"/>
+            <a:t>: try to eliminate or reduce MEV </a:t>
+          </a:r>
+          <a:r>
+            <a:rPr lang="en-US" sz="2000" u="none" kern="1200" dirty="0"/>
+            <a:t>opportunities</a:t>
+          </a:r>
+          <a:r>
+            <a:rPr lang="en-US" sz="2000" kern="1200" dirty="0"/>
+            <a:t>.</a:t>
           </a:r>
         </a:p>
       </dsp:txBody>
@@ -8362,12 +8391,12 @@
         <a:fontRef idx="minor"/>
       </dsp:style>
       <dsp:txBody>
-        <a:bodyPr spcFirstLastPara="0" vert="horz" wrap="square" lIns="91440" tIns="91440" rIns="91440" bIns="91440" numCol="1" spcCol="1270" anchor="t" anchorCtr="0">
+        <a:bodyPr spcFirstLastPara="0" vert="horz" wrap="square" lIns="76200" tIns="76200" rIns="76200" bIns="76200" numCol="1" spcCol="1270" anchor="t" anchorCtr="0">
           <a:noAutofit/>
         </a:bodyPr>
         <a:lstStyle/>
         <a:p>
-          <a:pPr marL="0" lvl="0" indent="0" algn="l" defTabSz="1066800">
+          <a:pPr marL="0" lvl="0" indent="0" algn="l" defTabSz="889000">
             <a:lnSpc>
               <a:spcPct val="90000"/>
             </a:lnSpc>
@@ -8380,12 +8409,12 @@
             <a:buNone/>
           </a:pPr>
           <a:r>
-            <a:rPr lang="en-US" sz="2400" b="1" kern="1200"/>
-            <a:t>Reducing its side effects</a:t>
+            <a:rPr lang="en-US" sz="2000" b="1" kern="1200" dirty="0"/>
+            <a:t>Side-effects Reduction</a:t>
           </a:r>
           <a:r>
-            <a:rPr lang="en-US" sz="2400" kern="1200"/>
-            <a:t>: try to make it less harmful and less centralized</a:t>
+            <a:rPr lang="en-US" sz="2000" kern="1200" dirty="0"/>
+            <a:t>: try to reduce the negative effects.</a:t>
           </a:r>
         </a:p>
       </dsp:txBody>
@@ -8965,7 +8994,7 @@
           </a14:m>
           <a:r>
             <a:rPr lang="en-US" sz="2000" kern="1200" dirty="0"/>
-            <a:t> = bid, meaning the tip paid by the user to gain priority</a:t>
+            <a:t> = bid (the tip paid by the user to gain priority)</a:t>
           </a:r>
           <a:endParaRPr lang="it-IT" sz="2000" kern="1200" dirty="0"/>
         </a:p>
@@ -9229,12 +9258,12 @@
         <a:fontRef idx="minor"/>
       </dsp:style>
       <dsp:txBody>
-        <a:bodyPr spcFirstLastPara="0" vert="horz" wrap="square" lIns="76200" tIns="76200" rIns="76200" bIns="76200" numCol="1" spcCol="1270" anchor="t" anchorCtr="0">
+        <a:bodyPr spcFirstLastPara="0" vert="horz" wrap="square" lIns="91440" tIns="91440" rIns="91440" bIns="91440" numCol="1" spcCol="1270" anchor="t" anchorCtr="0">
           <a:noAutofit/>
         </a:bodyPr>
         <a:lstStyle/>
         <a:p>
-          <a:pPr marL="0" lvl="0" indent="0" algn="l" defTabSz="889000">
+          <a:pPr marL="0" lvl="0" indent="0" algn="l" defTabSz="1066800">
             <a:lnSpc>
               <a:spcPct val="90000"/>
             </a:lnSpc>
@@ -9247,11 +9276,33 @@
             <a:buNone/>
           </a:pPr>
           <a:r>
-            <a:rPr lang="en-US" sz="2000" kern="1200" dirty="0"/>
+            <a:rPr lang="en-US" sz="2400" kern="1200" dirty="0">
+              <a:solidFill>
+                <a:prstClr val="black">
+                  <a:hueOff val="0"/>
+                  <a:satOff val="0"/>
+                  <a:lumOff val="0"/>
+                  <a:alphaOff val="0"/>
+                </a:prstClr>
+              </a:solidFill>
+              <a:latin typeface="Century Gothic" panose="020B0502020202020204"/>
+              <a:ea typeface="+mn-ea"/>
+              <a:cs typeface="+mn-cs"/>
+            </a:rPr>
             <a:t>Several nodes collaborate to decide transaction ordering instead of relying on a single operator. </a:t>
           </a:r>
-          <a:endParaRPr lang="en-GB" sz="2000" b="0" kern="1200" noProof="1">
-            <a:latin typeface="Aptos"/>
+          <a:endParaRPr lang="en-GB" sz="2400" kern="1200" noProof="1">
+            <a:solidFill>
+              <a:prstClr val="black">
+                <a:hueOff val="0"/>
+                <a:satOff val="0"/>
+                <a:lumOff val="0"/>
+                <a:alphaOff val="0"/>
+              </a:prstClr>
+            </a:solidFill>
+            <a:latin typeface="Century Gothic" panose="020B0502020202020204"/>
+            <a:ea typeface="+mn-ea"/>
+            <a:cs typeface="+mn-cs"/>
           </a:endParaRPr>
         </a:p>
       </dsp:txBody>
@@ -9260,7 +9311,7 @@
         <a:ext cx="9250723" cy="1045547"/>
       </dsp:txXfrm>
     </dsp:sp>
-    <dsp:sp modelId="{C123A4A3-C6B0-441F-8EF4-E9E43EBD83E7}">
+    <dsp:sp modelId="{66A3C529-44F3-4C22-9A20-D7276C7CAC47}">
       <dsp:nvSpPr>
         <dsp:cNvPr id="0" name=""/>
         <dsp:cNvSpPr/>
@@ -9309,7 +9360,7 @@
         </a:fontRef>
       </dsp:style>
     </dsp:sp>
-    <dsp:sp modelId="{80FB8A52-7AD5-4C62-8029-C035067A48D9}">
+    <dsp:sp modelId="{D43E5BD0-52EC-4245-9D86-6CD69D3AEED0}">
       <dsp:nvSpPr>
         <dsp:cNvPr id="0" name=""/>
         <dsp:cNvSpPr/>
@@ -9341,12 +9392,12 @@
         <a:fontRef idx="minor"/>
       </dsp:style>
       <dsp:txBody>
-        <a:bodyPr spcFirstLastPara="0" vert="horz" wrap="square" lIns="76200" tIns="76200" rIns="76200" bIns="76200" numCol="1" spcCol="1270" anchor="t" anchorCtr="0">
+        <a:bodyPr spcFirstLastPara="0" vert="horz" wrap="square" lIns="91440" tIns="91440" rIns="91440" bIns="91440" numCol="1" spcCol="1270" anchor="t" anchorCtr="0">
           <a:noAutofit/>
         </a:bodyPr>
         <a:lstStyle/>
         <a:p>
-          <a:pPr marL="0" lvl="0" indent="0" algn="l" defTabSz="889000" rtl="0">
+          <a:pPr marL="0" lvl="0" indent="0" algn="l" defTabSz="1066800">
             <a:lnSpc>
               <a:spcPct val="90000"/>
             </a:lnSpc>
@@ -9359,7 +9410,7 @@
             <a:buNone/>
           </a:pPr>
           <a:r>
-            <a:rPr lang="en-GB" sz="2000" kern="1200" noProof="1">
+            <a:rPr lang="en-GB" sz="2400" kern="1200" noProof="1">
               <a:solidFill>
                 <a:prstClr val="black">
                   <a:hueOff val="0"/>
@@ -9372,7 +9423,7 @@
               <a:ea typeface="+mn-ea"/>
               <a:cs typeface="+mn-cs"/>
             </a:rPr>
-            <a:t>One of the protocols discussed is Themis: each node submits its own local transaction ordering, and a leader attempts to construct a global ordering verified through cryptographic proofs.</a:t>
+            <a:t>Themis and Wendy: temporary leaders or synchronized timestamp across nodes</a:t>
           </a:r>
         </a:p>
       </dsp:txBody>
@@ -9381,7 +9432,7 @@
         <a:ext cx="9250723" cy="1045547"/>
       </dsp:txXfrm>
     </dsp:sp>
-    <dsp:sp modelId="{8F57034E-4A7F-429F-B43F-3EF04489A479}">
+    <dsp:sp modelId="{0748698C-D25C-4BF9-844E-D13628BC12BB}">
       <dsp:nvSpPr>
         <dsp:cNvPr id="0" name=""/>
         <dsp:cNvSpPr/>
@@ -9430,7 +9481,7 @@
         </a:fontRef>
       </dsp:style>
     </dsp:sp>
-    <dsp:sp modelId="{5E03B85D-0B36-4138-A85C-C849C3B245D8}">
+    <dsp:sp modelId="{A123DFA8-A85A-4398-B7F1-3218A71E99ED}">
       <dsp:nvSpPr>
         <dsp:cNvPr id="0" name=""/>
         <dsp:cNvSpPr/>
@@ -9462,12 +9513,12 @@
         <a:fontRef idx="minor"/>
       </dsp:style>
       <dsp:txBody>
-        <a:bodyPr spcFirstLastPara="0" vert="horz" wrap="square" lIns="76200" tIns="76200" rIns="76200" bIns="76200" numCol="1" spcCol="1270" anchor="t" anchorCtr="0">
+        <a:bodyPr spcFirstLastPara="0" vert="horz" wrap="square" lIns="91440" tIns="91440" rIns="91440" bIns="91440" numCol="1" spcCol="1270" anchor="t" anchorCtr="0">
           <a:noAutofit/>
         </a:bodyPr>
         <a:lstStyle/>
         <a:p>
-          <a:pPr marL="0" lvl="0" indent="0" algn="l" defTabSz="889000" rtl="0">
+          <a:pPr marL="0" lvl="0" indent="0" algn="l" defTabSz="1066800">
             <a:lnSpc>
               <a:spcPct val="90000"/>
             </a:lnSpc>
@@ -9480,7 +9531,7 @@
             <a:buNone/>
           </a:pPr>
           <a:r>
-            <a:rPr lang="en-GB" sz="2000" kern="1200" noProof="1">
+            <a:rPr lang="en-GB" sz="2400" kern="1200" noProof="1">
               <a:solidFill>
                 <a:prstClr val="black">
                   <a:hueOff val="0"/>
@@ -9493,7 +9544,7 @@
               <a:ea typeface="+mn-ea"/>
               <a:cs typeface="+mn-cs"/>
             </a:rPr>
-            <a:t>Another approach is Wendy, which uses synchronized timestamps to order transactions. </a:t>
+            <a:t>Require significant coordination and increase complexity and network overhead.</a:t>
           </a:r>
         </a:p>
       </dsp:txBody>
@@ -9521,8 +9572,8 @@
       </dsp:nvSpPr>
       <dsp:spPr>
         <a:xfrm rot="5400000">
-          <a:off x="5806720" y="-2401343"/>
-          <a:ext cx="845839" cy="5863191"/>
+          <a:off x="5975716" y="-2853318"/>
+          <a:ext cx="845839" cy="6767141"/>
         </a:xfrm>
         <a:prstGeom prst="round2SameRect">
           <a:avLst/>
@@ -9565,12 +9616,12 @@
         <a:fontRef idx="minor"/>
       </dsp:style>
       <dsp:txBody>
-        <a:bodyPr spcFirstLastPara="0" vert="horz" wrap="square" lIns="53340" tIns="26670" rIns="53340" bIns="26670" numCol="1" spcCol="1270" anchor="ctr" anchorCtr="0">
+        <a:bodyPr spcFirstLastPara="0" vert="horz" wrap="square" lIns="60960" tIns="30480" rIns="60960" bIns="30480" numCol="1" spcCol="1270" anchor="ctr" anchorCtr="0">
           <a:noAutofit/>
         </a:bodyPr>
         <a:lstStyle/>
         <a:p>
-          <a:pPr marL="114300" lvl="1" indent="-114300" algn="l" defTabSz="622300">
+          <a:pPr marL="171450" lvl="1" indent="-171450" algn="l" defTabSz="711200">
             <a:lnSpc>
               <a:spcPct val="90000"/>
             </a:lnSpc>
@@ -9583,13 +9634,13 @@
             <a:buChar char="•"/>
           </a:pPr>
           <a:r>
-            <a:rPr lang="en-US" sz="1400" kern="1200" dirty="0"/>
+            <a:rPr lang="en-US" sz="1600" kern="1200" dirty="0"/>
             <a:t>Transactions are encrypted</a:t>
           </a:r>
-          <a:endParaRPr lang="it-IT" sz="1400" kern="1200" dirty="0"/>
+          <a:endParaRPr lang="it-IT" sz="1600" kern="1200" dirty="0"/>
         </a:p>
         <a:p>
-          <a:pPr marL="114300" lvl="1" indent="-114300" algn="l" defTabSz="622300">
+          <a:pPr marL="171450" lvl="1" indent="-171450" algn="l" defTabSz="711200">
             <a:lnSpc>
               <a:spcPct val="90000"/>
             </a:lnSpc>
@@ -9602,15 +9653,15 @@
             <a:buChar char="•"/>
           </a:pPr>
           <a:r>
-            <a:rPr lang="en-US" sz="1400" kern="1200" dirty="0"/>
+            <a:rPr lang="en-US" sz="1600" kern="1200" dirty="0"/>
             <a:t>Decryption key is distributed among multiple parties</a:t>
           </a:r>
-          <a:endParaRPr lang="it-IT" sz="1400" kern="1200" dirty="0"/>
+          <a:endParaRPr lang="it-IT" sz="1600" kern="1200" dirty="0"/>
         </a:p>
       </dsp:txBody>
       <dsp:txXfrm rot="-5400000">
-        <a:off x="3298044" y="148623"/>
-        <a:ext cx="5821901" cy="763259"/>
+        <a:off x="3015065" y="148623"/>
+        <a:ext cx="6725851" cy="763259"/>
       </dsp:txXfrm>
     </dsp:sp>
     <dsp:sp modelId="{28AD86E7-8144-4D70-9CD4-38A296CE6AAC}">
@@ -9620,8 +9671,8 @@
       </dsp:nvSpPr>
       <dsp:spPr>
         <a:xfrm>
-          <a:off x="0" y="1601"/>
-          <a:ext cx="3298044" cy="1057299"/>
+          <a:off x="719165" y="1601"/>
+          <a:ext cx="2295900" cy="1057299"/>
         </a:xfrm>
         <a:prstGeom prst="roundRect">
           <a:avLst/>
@@ -9662,12 +9713,12 @@
         </a:fontRef>
       </dsp:style>
       <dsp:txBody>
-        <a:bodyPr spcFirstLastPara="0" vert="horz" wrap="square" lIns="102870" tIns="51435" rIns="102870" bIns="51435" numCol="1" spcCol="1270" anchor="ctr" anchorCtr="0">
+        <a:bodyPr spcFirstLastPara="0" vert="horz" wrap="square" lIns="91440" tIns="45720" rIns="91440" bIns="45720" numCol="1" spcCol="1270" anchor="ctr" anchorCtr="0">
           <a:noAutofit/>
         </a:bodyPr>
         <a:lstStyle/>
         <a:p>
-          <a:pPr marL="0" lvl="0" indent="0" algn="ctr" defTabSz="1200150">
+          <a:pPr marL="0" lvl="0" indent="0" algn="ctr" defTabSz="1066800">
             <a:lnSpc>
               <a:spcPct val="90000"/>
             </a:lnSpc>
@@ -9680,15 +9731,15 @@
             <a:buNone/>
           </a:pPr>
           <a:r>
-            <a:rPr lang="en-US" sz="2700" kern="1200" dirty="0"/>
+            <a:rPr lang="en-US" sz="2400" kern="1200" dirty="0"/>
             <a:t>Threshold Encryption</a:t>
           </a:r>
-          <a:endParaRPr lang="it-IT" sz="2700" kern="1200" dirty="0"/>
+          <a:endParaRPr lang="it-IT" sz="2400" kern="1200" dirty="0"/>
         </a:p>
       </dsp:txBody>
       <dsp:txXfrm>
-        <a:off x="51613" y="53214"/>
-        <a:ext cx="3194818" cy="954073"/>
+        <a:off x="770778" y="53214"/>
+        <a:ext cx="2192674" cy="954073"/>
       </dsp:txXfrm>
     </dsp:sp>
     <dsp:sp modelId="{1464F420-30C5-4EF9-8FE2-8B97BA384E65}">
@@ -9698,8 +9749,8 @@
       </dsp:nvSpPr>
       <dsp:spPr>
         <a:xfrm rot="5400000">
-          <a:off x="5806720" y="-1291179"/>
-          <a:ext cx="845839" cy="5863191"/>
+          <a:off x="6015342" y="-1743154"/>
+          <a:ext cx="845839" cy="6767141"/>
         </a:xfrm>
         <a:prstGeom prst="round2SameRect">
           <a:avLst/>
@@ -9742,12 +9793,12 @@
         <a:fontRef idx="minor"/>
       </dsp:style>
       <dsp:txBody>
-        <a:bodyPr spcFirstLastPara="0" vert="horz" wrap="square" lIns="53340" tIns="26670" rIns="53340" bIns="26670" numCol="1" spcCol="1270" anchor="ctr" anchorCtr="0">
+        <a:bodyPr spcFirstLastPara="0" vert="horz" wrap="square" lIns="60960" tIns="30480" rIns="60960" bIns="30480" numCol="1" spcCol="1270" anchor="ctr" anchorCtr="0">
           <a:noAutofit/>
         </a:bodyPr>
         <a:lstStyle/>
         <a:p>
-          <a:pPr marL="114300" lvl="1" indent="-114300" algn="l" defTabSz="622300">
+          <a:pPr marL="171450" lvl="1" indent="-171450" algn="l" defTabSz="711200">
             <a:lnSpc>
               <a:spcPct val="90000"/>
             </a:lnSpc>
@@ -9760,13 +9811,13 @@
             <a:buChar char="•"/>
           </a:pPr>
           <a:r>
-            <a:rPr lang="en-US" sz="1400" kern="1200" dirty="0"/>
+            <a:rPr lang="en-US" sz="1600" kern="1200" dirty="0"/>
             <a:t>The transaction remains encrypted for a certain period of time</a:t>
           </a:r>
-          <a:endParaRPr lang="it-IT" sz="1400" kern="1200" dirty="0"/>
+          <a:endParaRPr lang="it-IT" sz="1600" kern="1200" dirty="0"/>
         </a:p>
         <a:p>
-          <a:pPr marL="114300" lvl="1" indent="-114300" algn="l" defTabSz="622300">
+          <a:pPr marL="171450" lvl="1" indent="-171450" algn="l" defTabSz="711200">
             <a:lnSpc>
               <a:spcPct val="90000"/>
             </a:lnSpc>
@@ -9779,15 +9830,15 @@
             <a:buChar char="•"/>
           </a:pPr>
           <a:r>
-            <a:rPr lang="en-US" sz="1400" kern="1200" dirty="0"/>
+            <a:rPr lang="en-US" sz="1600" kern="1200" dirty="0"/>
             <a:t>Can only be obtained after solving a computational problem</a:t>
           </a:r>
-          <a:endParaRPr lang="it-IT" sz="1400" kern="1200" dirty="0"/>
+          <a:endParaRPr lang="it-IT" sz="1600" kern="1200" dirty="0"/>
         </a:p>
       </dsp:txBody>
       <dsp:txXfrm rot="-5400000">
-        <a:off x="3298044" y="1258787"/>
-        <a:ext cx="5821901" cy="763259"/>
+        <a:off x="3054691" y="1258787"/>
+        <a:ext cx="6725851" cy="763259"/>
       </dsp:txXfrm>
     </dsp:sp>
     <dsp:sp modelId="{DE2088EE-38A1-4533-883F-078B177E039D}">
@@ -9797,8 +9848,8 @@
       </dsp:nvSpPr>
       <dsp:spPr>
         <a:xfrm>
-          <a:off x="0" y="1111766"/>
-          <a:ext cx="3298044" cy="1057299"/>
+          <a:off x="719165" y="1111766"/>
+          <a:ext cx="2335526" cy="1057299"/>
         </a:xfrm>
         <a:prstGeom prst="roundRect">
           <a:avLst/>
@@ -9839,12 +9890,12 @@
         </a:fontRef>
       </dsp:style>
       <dsp:txBody>
-        <a:bodyPr spcFirstLastPara="0" vert="horz" wrap="square" lIns="102870" tIns="51435" rIns="102870" bIns="51435" numCol="1" spcCol="1270" anchor="ctr" anchorCtr="0">
+        <a:bodyPr spcFirstLastPara="0" vert="horz" wrap="square" lIns="91440" tIns="45720" rIns="91440" bIns="45720" numCol="1" spcCol="1270" anchor="ctr" anchorCtr="0">
           <a:noAutofit/>
         </a:bodyPr>
         <a:lstStyle/>
         <a:p>
-          <a:pPr marL="0" lvl="0" indent="0" algn="ctr" defTabSz="1200150">
+          <a:pPr marL="0" lvl="0" indent="0" algn="ctr" defTabSz="1066800">
             <a:lnSpc>
               <a:spcPct val="90000"/>
             </a:lnSpc>
@@ -9857,15 +9908,15 @@
             <a:buNone/>
           </a:pPr>
           <a:r>
-            <a:rPr lang="en-US" sz="2700" kern="1200" dirty="0"/>
+            <a:rPr lang="en-US" sz="2400" kern="1200" dirty="0"/>
             <a:t>Delay Encryption</a:t>
           </a:r>
-          <a:endParaRPr lang="it-IT" sz="2700" kern="1200" dirty="0"/>
+          <a:endParaRPr lang="it-IT" sz="2400" kern="1200" dirty="0"/>
         </a:p>
       </dsp:txBody>
       <dsp:txXfrm>
-        <a:off x="51613" y="1163379"/>
-        <a:ext cx="3194818" cy="954073"/>
+        <a:off x="770778" y="1163379"/>
+        <a:ext cx="2232300" cy="954073"/>
       </dsp:txXfrm>
     </dsp:sp>
     <dsp:sp modelId="{8CF9B37C-531F-477E-9A34-B6A5B6DBD5B6}">
@@ -9875,8 +9926,8 @@
       </dsp:nvSpPr>
       <dsp:spPr>
         <a:xfrm rot="5400000">
-          <a:off x="5806720" y="-181014"/>
-          <a:ext cx="845839" cy="5863191"/>
+          <a:off x="6048002" y="-632989"/>
+          <a:ext cx="845839" cy="6767141"/>
         </a:xfrm>
         <a:prstGeom prst="round2SameRect">
           <a:avLst/>
@@ -9919,12 +9970,12 @@
         <a:fontRef idx="minor"/>
       </dsp:style>
       <dsp:txBody>
-        <a:bodyPr spcFirstLastPara="0" vert="horz" wrap="square" lIns="53340" tIns="26670" rIns="53340" bIns="26670" numCol="1" spcCol="1270" anchor="ctr" anchorCtr="0">
+        <a:bodyPr spcFirstLastPara="0" vert="horz" wrap="square" lIns="60960" tIns="30480" rIns="60960" bIns="30480" numCol="1" spcCol="1270" anchor="ctr" anchorCtr="0">
           <a:noAutofit/>
         </a:bodyPr>
         <a:lstStyle/>
         <a:p>
-          <a:pPr marL="114300" lvl="1" indent="-114300" algn="l" defTabSz="622300">
+          <a:pPr marL="171450" lvl="1" indent="-171450" algn="l" defTabSz="711200">
             <a:lnSpc>
               <a:spcPct val="90000"/>
             </a:lnSpc>
@@ -9937,13 +9988,13 @@
             <a:buChar char="•"/>
           </a:pPr>
           <a:r>
-            <a:rPr lang="en-US" sz="1400" kern="1200" dirty="0"/>
+            <a:rPr lang="en-US" sz="1600" kern="1200" dirty="0"/>
             <a:t>Transactions are processed inside protected enclaves</a:t>
           </a:r>
-          <a:endParaRPr lang="it-IT" sz="1400" kern="1200" dirty="0"/>
+          <a:endParaRPr lang="it-IT" sz="1600" kern="1200" dirty="0"/>
         </a:p>
         <a:p>
-          <a:pPr marL="114300" lvl="1" indent="-114300" algn="l" defTabSz="622300">
+          <a:pPr marL="171450" lvl="1" indent="-171450" algn="l" defTabSz="711200">
             <a:lnSpc>
               <a:spcPct val="90000"/>
             </a:lnSpc>
@@ -9956,15 +10007,15 @@
             <a:buChar char="•"/>
           </a:pPr>
           <a:r>
-            <a:rPr lang="en-US" sz="1400" kern="1200" dirty="0"/>
+            <a:rPr lang="en-US" sz="1600" kern="1200" dirty="0"/>
             <a:t>Published only after execution</a:t>
           </a:r>
-          <a:endParaRPr lang="it-IT" sz="1400" kern="1200" dirty="0"/>
+          <a:endParaRPr lang="it-IT" sz="1600" kern="1200" dirty="0"/>
         </a:p>
       </dsp:txBody>
       <dsp:txXfrm rot="-5400000">
-        <a:off x="3298044" y="2368952"/>
-        <a:ext cx="5821901" cy="763259"/>
+        <a:off x="3087351" y="2368952"/>
+        <a:ext cx="6725851" cy="763259"/>
       </dsp:txXfrm>
     </dsp:sp>
     <dsp:sp modelId="{7A93E996-01DC-4918-816B-EB11EDF9F088}">
@@ -9974,8 +10025,8 @@
       </dsp:nvSpPr>
       <dsp:spPr>
         <a:xfrm>
-          <a:off x="0" y="2221931"/>
-          <a:ext cx="3298044" cy="1057299"/>
+          <a:off x="719165" y="2221931"/>
+          <a:ext cx="2368186" cy="1057299"/>
         </a:xfrm>
         <a:prstGeom prst="roundRect">
           <a:avLst/>
@@ -10016,12 +10067,12 @@
         </a:fontRef>
       </dsp:style>
       <dsp:txBody>
-        <a:bodyPr spcFirstLastPara="0" vert="horz" wrap="square" lIns="102870" tIns="51435" rIns="102870" bIns="51435" numCol="1" spcCol="1270" anchor="ctr" anchorCtr="0">
+        <a:bodyPr spcFirstLastPara="0" vert="horz" wrap="square" lIns="91440" tIns="45720" rIns="91440" bIns="45720" numCol="1" spcCol="1270" anchor="ctr" anchorCtr="0">
           <a:noAutofit/>
         </a:bodyPr>
         <a:lstStyle/>
         <a:p>
-          <a:pPr marL="0" lvl="0" indent="0" algn="ctr" defTabSz="1200150">
+          <a:pPr marL="0" lvl="0" indent="0" algn="ctr" defTabSz="1066800">
             <a:lnSpc>
               <a:spcPct val="90000"/>
             </a:lnSpc>
@@ -10034,15 +10085,15 @@
             <a:buNone/>
           </a:pPr>
           <a:r>
-            <a:rPr lang="en-US" sz="2700" kern="1200" dirty="0"/>
+            <a:rPr lang="en-US" sz="2400" kern="1200" dirty="0"/>
             <a:t>Trusted Execution Environments</a:t>
           </a:r>
-          <a:endParaRPr lang="it-IT" sz="2700" kern="1200" dirty="0"/>
+          <a:endParaRPr lang="it-IT" sz="2400" kern="1200" dirty="0"/>
         </a:p>
       </dsp:txBody>
       <dsp:txXfrm>
-        <a:off x="51613" y="2273544"/>
-        <a:ext cx="3194818" cy="954073"/>
+        <a:off x="770778" y="2273544"/>
+        <a:ext cx="2264960" cy="954073"/>
       </dsp:txXfrm>
     </dsp:sp>
   </dsp:spTree>
@@ -10644,27 +10695,11 @@
           </a:r>
           <a:r>
             <a:rPr lang="it-IT" sz="1600" kern="1200" dirty="0"/>
-            <a:t> the </a:t>
+            <a:t> the power of </a:t>
           </a:r>
           <a:r>
             <a:rPr lang="it-IT" sz="1600" kern="1200" dirty="0" err="1"/>
-            <a:t>validators</a:t>
-          </a:r>
-          <a:r>
-            <a:rPr lang="it-IT" sz="1600" kern="1200" dirty="0"/>
-            <a:t>’ </a:t>
-          </a:r>
-          <a:r>
-            <a:rPr lang="it-IT" sz="1600" kern="1200" dirty="0" err="1"/>
-            <a:t>direct</a:t>
-          </a:r>
-          <a:r>
-            <a:rPr lang="it-IT" sz="1600" kern="1200" dirty="0"/>
-            <a:t> power to </a:t>
-          </a:r>
-          <a:r>
-            <a:rPr lang="it-IT" sz="1600" kern="1200" dirty="0" err="1"/>
-            <a:t>manipulate</a:t>
+            <a:t>individual</a:t>
           </a:r>
           <a:r>
             <a:rPr lang="it-IT" sz="1600" kern="1200" dirty="0"/>
@@ -10672,7 +10707,7 @@
           </a:r>
           <a:r>
             <a:rPr lang="it-IT" sz="1600" kern="1200" dirty="0" err="1"/>
-            <a:t>transactions</a:t>
+            <a:t>validators</a:t>
           </a:r>
           <a:endParaRPr lang="en-US" sz="1600" b="0" i="0" u="none" strike="noStrike" kern="1200" baseline="0" dirty="0">
             <a:latin typeface="Aptos"/>
@@ -10832,28 +10867,36 @@
             <a:buNone/>
           </a:pPr>
           <a:r>
+            <a:rPr lang="it-IT" sz="1600" kern="1200" dirty="0" err="1"/>
+            <a:t>Introduces</a:t>
+          </a:r>
+          <a:r>
             <a:rPr lang="it-IT" sz="1600" kern="1200" dirty="0"/>
-            <a:t>The </a:t>
+            <a:t> new </a:t>
           </a:r>
           <a:r>
             <a:rPr lang="it-IT" sz="1600" kern="1200" dirty="0" err="1"/>
-            <a:t>problem</a:t>
+            <a:t>centralization</a:t>
           </a:r>
           <a:r>
             <a:rPr lang="it-IT" sz="1600" kern="1200" dirty="0"/>
-            <a:t> shifts from </a:t>
+            <a:t> risks </a:t>
           </a:r>
           <a:r>
             <a:rPr lang="it-IT" sz="1600" kern="1200" dirty="0" err="1"/>
-            <a:t>validators</a:t>
+            <a:t>around</a:t>
           </a:r>
           <a:r>
             <a:rPr lang="it-IT" sz="1600" kern="1200" dirty="0"/>
-            <a:t> to </a:t>
+            <a:t> </a:t>
           </a:r>
           <a:r>
             <a:rPr lang="it-IT" sz="1600" kern="1200" dirty="0" err="1"/>
             <a:t>relays</a:t>
+          </a:r>
+          <a:r>
+            <a:rPr lang="it-IT" sz="1600" kern="1200" dirty="0"/>
+            <a:t> and builders</a:t>
           </a:r>
           <a:endParaRPr lang="en-US" sz="1600" b="0" i="0" u="none" strike="noStrike" kern="1200" baseline="0" dirty="0">
             <a:latin typeface="Aptos"/>
@@ -20419,7 +20462,7 @@
           <a:p>
             <a:fld id="{4AAD347D-5ACD-4C99-B74B-A9C85AD731AF}" type="datetimeFigureOut">
               <a:rPr lang="en-US" smtClean="0"/>
-              <a:t>5/15/2026</a:t>
+              <a:t>5/31/2026</a:t>
             </a:fld>
             <a:endParaRPr lang="en-US" dirty="0"/>
           </a:p>
@@ -20694,7 +20737,7 @@
           <a:p>
             <a:fld id="{4509A250-FF31-4206-8172-F9D3106AACB1}" type="datetimeFigureOut">
               <a:rPr lang="en-US" smtClean="0"/>
-              <a:t>5/15/2026</a:t>
+              <a:t>5/31/2026</a:t>
             </a:fld>
             <a:endParaRPr lang="en-US" dirty="0"/>
           </a:p>
@@ -20888,7 +20931,7 @@
           <a:p>
             <a:fld id="{4509A250-FF31-4206-8172-F9D3106AACB1}" type="datetimeFigureOut">
               <a:rPr lang="en-US" smtClean="0"/>
-              <a:t>5/15/2026</a:t>
+              <a:t>5/31/2026</a:t>
             </a:fld>
             <a:endParaRPr lang="en-US" dirty="0"/>
           </a:p>
@@ -21161,7 +21204,7 @@
           <a:p>
             <a:fld id="{4509A250-FF31-4206-8172-F9D3106AACB1}" type="datetimeFigureOut">
               <a:rPr lang="en-US" smtClean="0"/>
-              <a:t>5/15/2026</a:t>
+              <a:t>5/31/2026</a:t>
             </a:fld>
             <a:endParaRPr lang="en-US" dirty="0"/>
           </a:p>
@@ -21503,7 +21546,7 @@
           <a:p>
             <a:fld id="{4509A250-FF31-4206-8172-F9D3106AACB1}" type="datetimeFigureOut">
               <a:rPr lang="en-US" smtClean="0"/>
-              <a:t>5/15/2026</a:t>
+              <a:t>5/31/2026</a:t>
             </a:fld>
             <a:endParaRPr lang="en-US" dirty="0"/>
           </a:p>
@@ -22126,7 +22169,7 @@
           <a:p>
             <a:fld id="{4509A250-FF31-4206-8172-F9D3106AACB1}" type="datetimeFigureOut">
               <a:rPr lang="en-US" smtClean="0"/>
-              <a:t>5/15/2026</a:t>
+              <a:t>5/31/2026</a:t>
             </a:fld>
             <a:endParaRPr lang="en-US" dirty="0"/>
           </a:p>
@@ -22986,7 +23029,7 @@
           <a:p>
             <a:fld id="{4509A250-FF31-4206-8172-F9D3106AACB1}" type="datetimeFigureOut">
               <a:rPr lang="en-US" smtClean="0"/>
-              <a:t>5/15/2026</a:t>
+              <a:t>5/31/2026</a:t>
             </a:fld>
             <a:endParaRPr lang="en-US" dirty="0"/>
           </a:p>
@@ -23156,7 +23199,7 @@
           <a:p>
             <a:fld id="{4509A250-FF31-4206-8172-F9D3106AACB1}" type="datetimeFigureOut">
               <a:rPr lang="en-US" smtClean="0"/>
-              <a:t>5/15/2026</a:t>
+              <a:t>5/31/2026</a:t>
             </a:fld>
             <a:endParaRPr lang="en-US" dirty="0"/>
           </a:p>
@@ -23336,7 +23379,7 @@
           <a:p>
             <a:fld id="{4509A250-FF31-4206-8172-F9D3106AACB1}" type="datetimeFigureOut">
               <a:rPr lang="en-US" smtClean="0"/>
-              <a:t>5/15/2026</a:t>
+              <a:t>5/31/2026</a:t>
             </a:fld>
             <a:endParaRPr lang="en-US" dirty="0"/>
           </a:p>
@@ -23507,7 +23550,7 @@
           <a:p>
             <a:fld id="{4509A250-FF31-4206-8172-F9D3106AACB1}" type="datetimeFigureOut">
               <a:rPr lang="en-US" smtClean="0"/>
-              <a:t>5/15/2026</a:t>
+              <a:t>5/31/2026</a:t>
             </a:fld>
             <a:endParaRPr lang="en-US" dirty="0"/>
           </a:p>
@@ -23754,7 +23797,7 @@
           <a:p>
             <a:fld id="{4509A250-FF31-4206-8172-F9D3106AACB1}" type="datetimeFigureOut">
               <a:rPr lang="en-US" smtClean="0"/>
-              <a:t>5/15/2026</a:t>
+              <a:t>5/31/2026</a:t>
             </a:fld>
             <a:endParaRPr lang="en-US" dirty="0"/>
           </a:p>
@@ -24046,7 +24089,7 @@
           <a:p>
             <a:fld id="{4509A250-FF31-4206-8172-F9D3106AACB1}" type="datetimeFigureOut">
               <a:rPr lang="en-US" smtClean="0"/>
-              <a:t>5/15/2026</a:t>
+              <a:t>5/31/2026</a:t>
             </a:fld>
             <a:endParaRPr lang="en-US" dirty="0"/>
           </a:p>
@@ -24490,7 +24533,7 @@
           <a:p>
             <a:fld id="{4509A250-FF31-4206-8172-F9D3106AACB1}" type="datetimeFigureOut">
               <a:rPr lang="en-US" smtClean="0"/>
-              <a:t>5/15/2026</a:t>
+              <a:t>5/31/2026</a:t>
             </a:fld>
             <a:endParaRPr lang="en-US" dirty="0"/>
           </a:p>
@@ -24608,7 +24651,7 @@
           <a:p>
             <a:fld id="{4509A250-FF31-4206-8172-F9D3106AACB1}" type="datetimeFigureOut">
               <a:rPr lang="en-US" smtClean="0"/>
-              <a:t>5/15/2026</a:t>
+              <a:t>5/31/2026</a:t>
             </a:fld>
             <a:endParaRPr lang="en-US" dirty="0"/>
           </a:p>
@@ -24703,7 +24746,7 @@
           <a:p>
             <a:fld id="{4509A250-FF31-4206-8172-F9D3106AACB1}" type="datetimeFigureOut">
               <a:rPr lang="en-US" smtClean="0"/>
-              <a:t>5/15/2026</a:t>
+              <a:t>5/31/2026</a:t>
             </a:fld>
             <a:endParaRPr lang="en-US" dirty="0"/>
           </a:p>
@@ -24982,7 +25025,7 @@
           <a:p>
             <a:fld id="{4509A250-FF31-4206-8172-F9D3106AACB1}" type="datetimeFigureOut">
               <a:rPr lang="en-US" smtClean="0"/>
-              <a:t>5/15/2026</a:t>
+              <a:t>5/31/2026</a:t>
             </a:fld>
             <a:endParaRPr lang="en-US" dirty="0"/>
           </a:p>
@@ -25257,7 +25300,7 @@
           <a:p>
             <a:fld id="{4509A250-FF31-4206-8172-F9D3106AACB1}" type="datetimeFigureOut">
               <a:rPr lang="en-US" smtClean="0"/>
-              <a:t>5/15/2026</a:t>
+              <a:t>5/31/2026</a:t>
             </a:fld>
             <a:endParaRPr lang="en-US" dirty="0"/>
           </a:p>
@@ -25686,7 +25729,7 @@
           <a:p>
             <a:fld id="{4509A250-FF31-4206-8172-F9D3106AACB1}" type="datetimeFigureOut">
               <a:rPr lang="en-US" smtClean="0"/>
-              <a:t>5/15/2026</a:t>
+              <a:t>5/31/2026</a:t>
             </a:fld>
             <a:endParaRPr lang="en-US" dirty="0"/>
           </a:p>
@@ -28165,7 +28208,7 @@
           <p:nvPr>
             <p:extLst>
               <p:ext uri="{D42A27DB-BD31-4B8C-83A1-F6EECF244321}">
-                <p14:modId xmlns:p14="http://schemas.microsoft.com/office/powerpoint/2010/main" val="2302929294"/>
+                <p14:modId xmlns:p14="http://schemas.microsoft.com/office/powerpoint/2010/main" val="2880429647"/>
               </p:ext>
             </p:extLst>
           </p:nvPr>
@@ -29277,7 +29320,7 @@
           <a:lstStyle/>
           <a:p>
             <a:r>
-              <a:rPr lang="en-US" sz="2400" dirty="0">
+              <a:rPr lang="it-IT" sz="2400" dirty="0" err="1">
                 <a:solidFill>
                   <a:prstClr val="black">
                     <a:hueOff val="0"/>
@@ -29288,19 +29331,218 @@
                 </a:solidFill>
                 <a:latin typeface="Century Gothic" panose="020B0502020202020204"/>
               </a:rPr>
-              <a:t>A fair ordering policy is a method designed to eliminate a sequencer’s ability to reorder transactions.</a:t>
+              <a:t>If</a:t>
             </a:r>
-            <a:endParaRPr lang="it-IT" sz="2400" dirty="0">
-              <a:solidFill>
-                <a:prstClr val="black">
-                  <a:hueOff val="0"/>
-                  <a:satOff val="0"/>
-                  <a:lumOff val="0"/>
-                  <a:alphaOff val="0"/>
-                </a:prstClr>
-              </a:solidFill>
-              <a:latin typeface="Century Gothic" panose="020B0502020202020204"/>
-            </a:endParaRPr>
+            <a:r>
+              <a:rPr lang="it-IT" sz="2400" dirty="0">
+                <a:solidFill>
+                  <a:prstClr val="black">
+                    <a:hueOff val="0"/>
+                    <a:satOff val="0"/>
+                    <a:lumOff val="0"/>
+                    <a:alphaOff val="0"/>
+                  </a:prstClr>
+                </a:solidFill>
+                <a:latin typeface="Century Gothic" panose="020B0502020202020204"/>
+              </a:rPr>
+              <a:t> the </a:t>
+            </a:r>
+            <a:r>
+              <a:rPr lang="it-IT" sz="2400" dirty="0" err="1">
+                <a:solidFill>
+                  <a:prstClr val="black">
+                    <a:hueOff val="0"/>
+                    <a:satOff val="0"/>
+                    <a:lumOff val="0"/>
+                    <a:alphaOff val="0"/>
+                  </a:prstClr>
+                </a:solidFill>
+                <a:latin typeface="Century Gothic" panose="020B0502020202020204"/>
+              </a:rPr>
+              <a:t>problem</a:t>
+            </a:r>
+            <a:r>
+              <a:rPr lang="it-IT" sz="2400" dirty="0">
+                <a:solidFill>
+                  <a:prstClr val="black">
+                    <a:hueOff val="0"/>
+                    <a:satOff val="0"/>
+                    <a:lumOff val="0"/>
+                    <a:alphaOff val="0"/>
+                  </a:prstClr>
+                </a:solidFill>
+                <a:latin typeface="Century Gothic" panose="020B0502020202020204"/>
+              </a:rPr>
+              <a:t> </a:t>
+            </a:r>
+            <a:r>
+              <a:rPr lang="it-IT" sz="2400" dirty="0" err="1">
+                <a:solidFill>
+                  <a:prstClr val="black">
+                    <a:hueOff val="0"/>
+                    <a:satOff val="0"/>
+                    <a:lumOff val="0"/>
+                    <a:alphaOff val="0"/>
+                  </a:prstClr>
+                </a:solidFill>
+                <a:latin typeface="Century Gothic" panose="020B0502020202020204"/>
+              </a:rPr>
+              <a:t>arise</a:t>
+            </a:r>
+            <a:r>
+              <a:rPr lang="it-IT" sz="2400" dirty="0">
+                <a:solidFill>
+                  <a:prstClr val="black">
+                    <a:hueOff val="0"/>
+                    <a:satOff val="0"/>
+                    <a:lumOff val="0"/>
+                    <a:alphaOff val="0"/>
+                  </a:prstClr>
+                </a:solidFill>
+                <a:latin typeface="Century Gothic" panose="020B0502020202020204"/>
+              </a:rPr>
+              <a:t> </a:t>
+            </a:r>
+            <a:r>
+              <a:rPr lang="it-IT" sz="2400" dirty="0" err="1">
+                <a:solidFill>
+                  <a:prstClr val="black">
+                    <a:hueOff val="0"/>
+                    <a:satOff val="0"/>
+                    <a:lumOff val="0"/>
+                    <a:alphaOff val="0"/>
+                  </a:prstClr>
+                </a:solidFill>
+                <a:latin typeface="Century Gothic" panose="020B0502020202020204"/>
+              </a:rPr>
+              <a:t>because</a:t>
+            </a:r>
+            <a:r>
+              <a:rPr lang="it-IT" sz="2400" dirty="0">
+                <a:solidFill>
+                  <a:prstClr val="black">
+                    <a:hueOff val="0"/>
+                    <a:satOff val="0"/>
+                    <a:lumOff val="0"/>
+                    <a:alphaOff val="0"/>
+                  </a:prstClr>
+                </a:solidFill>
+                <a:latin typeface="Century Gothic" panose="020B0502020202020204"/>
+              </a:rPr>
+              <a:t> </a:t>
+            </a:r>
+            <a:r>
+              <a:rPr lang="it-IT" sz="2400" dirty="0" err="1">
+                <a:solidFill>
+                  <a:prstClr val="black">
+                    <a:hueOff val="0"/>
+                    <a:satOff val="0"/>
+                    <a:lumOff val="0"/>
+                    <a:alphaOff val="0"/>
+                  </a:prstClr>
+                </a:solidFill>
+                <a:latin typeface="Century Gothic" panose="020B0502020202020204"/>
+              </a:rPr>
+              <a:t>sequencer</a:t>
+            </a:r>
+            <a:r>
+              <a:rPr lang="it-IT" sz="2400" dirty="0">
+                <a:solidFill>
+                  <a:prstClr val="black">
+                    <a:hueOff val="0"/>
+                    <a:satOff val="0"/>
+                    <a:lumOff val="0"/>
+                    <a:alphaOff val="0"/>
+                  </a:prstClr>
+                </a:solidFill>
+                <a:latin typeface="Century Gothic" panose="020B0502020202020204"/>
+              </a:rPr>
+              <a:t> can </a:t>
+            </a:r>
+            <a:r>
+              <a:rPr lang="it-IT" sz="2400" dirty="0" err="1">
+                <a:solidFill>
+                  <a:prstClr val="black">
+                    <a:hueOff val="0"/>
+                    <a:satOff val="0"/>
+                    <a:lumOff val="0"/>
+                    <a:alphaOff val="0"/>
+                  </a:prstClr>
+                </a:solidFill>
+                <a:latin typeface="Century Gothic" panose="020B0502020202020204"/>
+              </a:rPr>
+              <a:t>reorder</a:t>
+            </a:r>
+            <a:r>
+              <a:rPr lang="it-IT" sz="2400" dirty="0">
+                <a:solidFill>
+                  <a:prstClr val="black">
+                    <a:hueOff val="0"/>
+                    <a:satOff val="0"/>
+                    <a:lumOff val="0"/>
+                    <a:alphaOff val="0"/>
+                  </a:prstClr>
+                </a:solidFill>
+                <a:latin typeface="Century Gothic" panose="020B0502020202020204"/>
+              </a:rPr>
+              <a:t> </a:t>
+            </a:r>
+            <a:r>
+              <a:rPr lang="it-IT" sz="2400" dirty="0" err="1">
+                <a:solidFill>
+                  <a:prstClr val="black">
+                    <a:hueOff val="0"/>
+                    <a:satOff val="0"/>
+                    <a:lumOff val="0"/>
+                    <a:alphaOff val="0"/>
+                  </a:prstClr>
+                </a:solidFill>
+                <a:latin typeface="Century Gothic" panose="020B0502020202020204"/>
+              </a:rPr>
+              <a:t>transaction</a:t>
+            </a:r>
+            <a:r>
+              <a:rPr lang="it-IT" sz="2400" dirty="0">
+                <a:solidFill>
+                  <a:prstClr val="black">
+                    <a:hueOff val="0"/>
+                    <a:satOff val="0"/>
+                    <a:lumOff val="0"/>
+                    <a:alphaOff val="0"/>
+                  </a:prstClr>
+                </a:solidFill>
+                <a:latin typeface="Century Gothic" panose="020B0502020202020204"/>
+              </a:rPr>
+              <a:t> </a:t>
+            </a:r>
+            <a:r>
+              <a:rPr lang="it-IT" sz="2400" dirty="0" err="1">
+                <a:solidFill>
+                  <a:prstClr val="black">
+                    <a:hueOff val="0"/>
+                    <a:satOff val="0"/>
+                    <a:lumOff val="0"/>
+                    <a:alphaOff val="0"/>
+                  </a:prstClr>
+                </a:solidFill>
+                <a:latin typeface="Century Gothic" panose="020B0502020202020204"/>
+              </a:rPr>
+              <a:t>then</a:t>
+            </a:r>
+            <a:r>
+              <a:rPr lang="it-IT" sz="2400" dirty="0">
+                <a:solidFill>
+                  <a:prstClr val="black">
+                    <a:hueOff val="0"/>
+                    <a:satOff val="0"/>
+                    <a:lumOff val="0"/>
+                    <a:alphaOff val="0"/>
+                  </a:prstClr>
+                </a:solidFill>
+                <a:latin typeface="Century Gothic" panose="020B0502020202020204"/>
+              </a:rPr>
+              <a:t> precise rule must be introduce.</a:t>
+            </a:r>
           </a:p>
           <a:p>
             <a:endParaRPr lang="en-US" sz="2400" dirty="0">
@@ -30451,14 +30693,14 @@
           </a:p>
           <a:p>
             <a:r>
-              <a:rPr lang="it-IT" sz="2400" i="1" dirty="0">
+              <a:rPr lang="it-IT" sz="2400" i="1" u="sng" dirty="0">
                 <a:ea typeface="+mn-lt"/>
                 <a:cs typeface="+mn-lt"/>
               </a:rPr>
-              <a:t>First Come First Serve</a:t>
+              <a:t>First Come First Serve policy</a:t>
             </a:r>
             <a:r>
-              <a:rPr lang="it-IT" sz="2400" dirty="0">
+              <a:rPr lang="it-IT" sz="2400" u="sng" dirty="0">
                 <a:ea typeface="+mn-lt"/>
                 <a:cs typeface="+mn-lt"/>
               </a:rPr>
@@ -31856,7 +32098,7 @@
             </a:pPr>
             <a:r>
               <a:rPr lang="en-US" sz="2000" dirty="0"/>
-              <a:t>a timestamp;</a:t>
+              <a:t>a timestamp</a:t>
             </a:r>
           </a:p>
           <a:p>
@@ -31866,7 +32108,7 @@
             </a:pPr>
             <a:r>
               <a:rPr lang="en-US" sz="2000" dirty="0"/>
-              <a:t>and an economic bid. </a:t>
+              <a:t>an economic bid</a:t>
             </a:r>
             <a:endParaRPr lang="it-IT" sz="2000" dirty="0">
               <a:solidFill>
@@ -31987,7 +32229,7 @@
               <p:nvPr>
                 <p:extLst>
                   <p:ext uri="{D42A27DB-BD31-4B8C-83A1-F6EECF244321}">
-                    <p14:modId xmlns:p14="http://schemas.microsoft.com/office/powerpoint/2010/main" val="3746714529"/>
+                    <p14:modId xmlns:p14="http://schemas.microsoft.com/office/powerpoint/2010/main" val="4191622208"/>
                   </p:ext>
                 </p:extLst>
               </p:nvPr>
@@ -32017,7 +32259,7 @@
               <p:nvPr>
                 <p:extLst>
                   <p:ext uri="{D42A27DB-BD31-4B8C-83A1-F6EECF244321}">
-                    <p14:modId xmlns:p14="http://schemas.microsoft.com/office/powerpoint/2010/main" val="3746714529"/>
+                    <p14:modId xmlns:p14="http://schemas.microsoft.com/office/powerpoint/2010/main" val="4191622208"/>
                   </p:ext>
                 </p:extLst>
               </p:nvPr>
@@ -33094,7 +33336,7 @@
           <p:nvPr>
             <p:extLst>
               <p:ext uri="{D42A27DB-BD31-4B8C-83A1-F6EECF244321}">
-                <p14:modId xmlns:p14="http://schemas.microsoft.com/office/powerpoint/2010/main" val="3326773752"/>
+                <p14:modId xmlns:p14="http://schemas.microsoft.com/office/powerpoint/2010/main" val="1608528531"/>
               </p:ext>
             </p:extLst>
           </p:nvPr>
@@ -34220,10 +34462,20 @@
           <a:lstStyle/>
           <a:p>
             <a:r>
-              <a:rPr lang="en-US" sz="2000" dirty="0"/>
+              <a:rPr lang="en-US" sz="2000" dirty="0">
+                <a:solidFill>
+                  <a:prstClr val="black">
+                    <a:hueOff val="0"/>
+                    <a:satOff val="0"/>
+                    <a:lumOff val="0"/>
+                    <a:alphaOff val="0"/>
+                  </a:prstClr>
+                </a:solidFill>
+                <a:latin typeface="Century Gothic" panose="020B0502020202020204"/>
+              </a:rPr>
               <a:t>Transaction contents are hidden until the ordering has already been decided.</a:t>
             </a:r>
-            <a:endParaRPr lang="it-IT" dirty="0"/>
+            <a:endParaRPr lang="it-IT" sz="1600" dirty="0"/>
           </a:p>
         </p:txBody>
       </p:sp>
@@ -34312,14 +34564,14 @@
           <p:nvPr>
             <p:extLst>
               <p:ext uri="{D42A27DB-BD31-4B8C-83A1-F6EECF244321}">
-                <p14:modId xmlns:p14="http://schemas.microsoft.com/office/powerpoint/2010/main" val="719064617"/>
+                <p14:modId xmlns:p14="http://schemas.microsoft.com/office/powerpoint/2010/main" val="4264816229"/>
               </p:ext>
             </p:extLst>
           </p:nvPr>
         </p:nvGraphicFramePr>
         <p:xfrm>
-          <a:off x="774700" y="3075490"/>
-          <a:ext cx="9161236" cy="3280833"/>
+          <a:off x="0" y="3133591"/>
+          <a:ext cx="10573658" cy="3280833"/>
         </p:xfrm>
         <a:graphic>
           <a:graphicData uri="http://schemas.openxmlformats.org/drawingml/2006/diagram">
@@ -35357,9 +35609,12 @@
             </a:r>
           </a:p>
           <a:p>
-            <a:pPr marL="457200" indent="-457200">
-              <a:buFont typeface="+mj-lt"/>
-              <a:buAutoNum type="arabicPeriod"/>
+            <a:pPr>
+              <a:buClr>
+                <a:schemeClr val="tx1"/>
+              </a:buClr>
+              <a:buFont typeface="Wingdings" panose="05000000000000000000" pitchFamily="2" charset="2"/>
+              <a:buChar char="Ø"/>
             </a:pPr>
             <a:r>
               <a:rPr lang="en-US" dirty="0"/>
@@ -35375,9 +35630,12 @@
             </a:r>
           </a:p>
           <a:p>
-            <a:pPr marL="457200" indent="-457200">
-              <a:buFont typeface="+mj-lt"/>
-              <a:buAutoNum type="arabicPeriod"/>
+            <a:pPr>
+              <a:buClr>
+                <a:schemeClr val="tx1"/>
+              </a:buClr>
+              <a:buFont typeface="Wingdings" panose="05000000000000000000" pitchFamily="2" charset="2"/>
+              <a:buChar char="Ø"/>
             </a:pPr>
             <a:r>
               <a:rPr lang="en-US" b="1" dirty="0"/>
@@ -35385,7 +35643,7 @@
             </a:r>
             <a:r>
               <a:rPr lang="en-US" dirty="0"/>
-              <a:t> components connected to the blockchain ecosystem. An important example is </a:t>
+              <a:t> components connected to the blockchain ecosystem. Some important example are </a:t>
             </a:r>
             <a:r>
               <a:rPr lang="en-US" dirty="0" err="1"/>
@@ -35393,7 +35651,7 @@
             </a:r>
             <a:r>
               <a:rPr lang="en-US" dirty="0"/>
-              <a:t> Swap.</a:t>
+              <a:t> Swap and Fair MM.</a:t>
             </a:r>
           </a:p>
           <a:p>
@@ -36646,7 +36904,7 @@
           <p:nvPr>
             <p:extLst>
               <p:ext uri="{D42A27DB-BD31-4B8C-83A1-F6EECF244321}">
-                <p14:modId xmlns:p14="http://schemas.microsoft.com/office/powerpoint/2010/main" val="2318793700"/>
+                <p14:modId xmlns:p14="http://schemas.microsoft.com/office/powerpoint/2010/main" val="472727485"/>
               </p:ext>
             </p:extLst>
           </p:nvPr>

</xml_diff>

<commit_message>
Correzione errore overload infura too many request
</commit_message>
<xml_diff>
--- a/SEMINARIO/MEV.pptx
+++ b/SEMINARIO/MEV.pptx
@@ -5800,7 +5800,7 @@
         <a:p>
           <a:r>
             <a:rPr lang="en-US" dirty="0"/>
-            <a:t>new problems emerge: </a:t>
+            <a:t>New problems emerge: </a:t>
           </a:r>
         </a:p>
       </dgm:t>
@@ -8649,7 +8649,7 @@
           </a:pPr>
           <a:r>
             <a:rPr lang="en-US" sz="2000" kern="1200" dirty="0"/>
-            <a:t>new problems emerge: </a:t>
+            <a:t>New problems emerge: </a:t>
           </a:r>
         </a:p>
       </dsp:txBody>
@@ -20462,7 +20462,7 @@
           <a:p>
             <a:fld id="{4AAD347D-5ACD-4C99-B74B-A9C85AD731AF}" type="datetimeFigureOut">
               <a:rPr lang="en-US" smtClean="0"/>
-              <a:t>6/1/2026</a:t>
+              <a:t>6/2/2026</a:t>
             </a:fld>
             <a:endParaRPr lang="en-US" dirty="0"/>
           </a:p>
@@ -20737,7 +20737,7 @@
           <a:p>
             <a:fld id="{4509A250-FF31-4206-8172-F9D3106AACB1}" type="datetimeFigureOut">
               <a:rPr lang="en-US" smtClean="0"/>
-              <a:t>6/1/2026</a:t>
+              <a:t>6/2/2026</a:t>
             </a:fld>
             <a:endParaRPr lang="en-US" dirty="0"/>
           </a:p>
@@ -20931,7 +20931,7 @@
           <a:p>
             <a:fld id="{4509A250-FF31-4206-8172-F9D3106AACB1}" type="datetimeFigureOut">
               <a:rPr lang="en-US" smtClean="0"/>
-              <a:t>6/1/2026</a:t>
+              <a:t>6/2/2026</a:t>
             </a:fld>
             <a:endParaRPr lang="en-US" dirty="0"/>
           </a:p>
@@ -21204,7 +21204,7 @@
           <a:p>
             <a:fld id="{4509A250-FF31-4206-8172-F9D3106AACB1}" type="datetimeFigureOut">
               <a:rPr lang="en-US" smtClean="0"/>
-              <a:t>6/1/2026</a:t>
+              <a:t>6/2/2026</a:t>
             </a:fld>
             <a:endParaRPr lang="en-US" dirty="0"/>
           </a:p>
@@ -21546,7 +21546,7 @@
           <a:p>
             <a:fld id="{4509A250-FF31-4206-8172-F9D3106AACB1}" type="datetimeFigureOut">
               <a:rPr lang="en-US" smtClean="0"/>
-              <a:t>6/1/2026</a:t>
+              <a:t>6/2/2026</a:t>
             </a:fld>
             <a:endParaRPr lang="en-US" dirty="0"/>
           </a:p>
@@ -22169,7 +22169,7 @@
           <a:p>
             <a:fld id="{4509A250-FF31-4206-8172-F9D3106AACB1}" type="datetimeFigureOut">
               <a:rPr lang="en-US" smtClean="0"/>
-              <a:t>6/1/2026</a:t>
+              <a:t>6/2/2026</a:t>
             </a:fld>
             <a:endParaRPr lang="en-US" dirty="0"/>
           </a:p>
@@ -23029,7 +23029,7 @@
           <a:p>
             <a:fld id="{4509A250-FF31-4206-8172-F9D3106AACB1}" type="datetimeFigureOut">
               <a:rPr lang="en-US" smtClean="0"/>
-              <a:t>6/1/2026</a:t>
+              <a:t>6/2/2026</a:t>
             </a:fld>
             <a:endParaRPr lang="en-US" dirty="0"/>
           </a:p>
@@ -23199,7 +23199,7 @@
           <a:p>
             <a:fld id="{4509A250-FF31-4206-8172-F9D3106AACB1}" type="datetimeFigureOut">
               <a:rPr lang="en-US" smtClean="0"/>
-              <a:t>6/1/2026</a:t>
+              <a:t>6/2/2026</a:t>
             </a:fld>
             <a:endParaRPr lang="en-US" dirty="0"/>
           </a:p>
@@ -23379,7 +23379,7 @@
           <a:p>
             <a:fld id="{4509A250-FF31-4206-8172-F9D3106AACB1}" type="datetimeFigureOut">
               <a:rPr lang="en-US" smtClean="0"/>
-              <a:t>6/1/2026</a:t>
+              <a:t>6/2/2026</a:t>
             </a:fld>
             <a:endParaRPr lang="en-US" dirty="0"/>
           </a:p>
@@ -23550,7 +23550,7 @@
           <a:p>
             <a:fld id="{4509A250-FF31-4206-8172-F9D3106AACB1}" type="datetimeFigureOut">
               <a:rPr lang="en-US" smtClean="0"/>
-              <a:t>6/1/2026</a:t>
+              <a:t>6/2/2026</a:t>
             </a:fld>
             <a:endParaRPr lang="en-US" dirty="0"/>
           </a:p>
@@ -23797,7 +23797,7 @@
           <a:p>
             <a:fld id="{4509A250-FF31-4206-8172-F9D3106AACB1}" type="datetimeFigureOut">
               <a:rPr lang="en-US" smtClean="0"/>
-              <a:t>6/1/2026</a:t>
+              <a:t>6/2/2026</a:t>
             </a:fld>
             <a:endParaRPr lang="en-US" dirty="0"/>
           </a:p>
@@ -24089,7 +24089,7 @@
           <a:p>
             <a:fld id="{4509A250-FF31-4206-8172-F9D3106AACB1}" type="datetimeFigureOut">
               <a:rPr lang="en-US" smtClean="0"/>
-              <a:t>6/1/2026</a:t>
+              <a:t>6/2/2026</a:t>
             </a:fld>
             <a:endParaRPr lang="en-US" dirty="0"/>
           </a:p>
@@ -24533,7 +24533,7 @@
           <a:p>
             <a:fld id="{4509A250-FF31-4206-8172-F9D3106AACB1}" type="datetimeFigureOut">
               <a:rPr lang="en-US" smtClean="0"/>
-              <a:t>6/1/2026</a:t>
+              <a:t>6/2/2026</a:t>
             </a:fld>
             <a:endParaRPr lang="en-US" dirty="0"/>
           </a:p>
@@ -24651,7 +24651,7 @@
           <a:p>
             <a:fld id="{4509A250-FF31-4206-8172-F9D3106AACB1}" type="datetimeFigureOut">
               <a:rPr lang="en-US" smtClean="0"/>
-              <a:t>6/1/2026</a:t>
+              <a:t>6/2/2026</a:t>
             </a:fld>
             <a:endParaRPr lang="en-US" dirty="0"/>
           </a:p>
@@ -24746,7 +24746,7 @@
           <a:p>
             <a:fld id="{4509A250-FF31-4206-8172-F9D3106AACB1}" type="datetimeFigureOut">
               <a:rPr lang="en-US" smtClean="0"/>
-              <a:t>6/1/2026</a:t>
+              <a:t>6/2/2026</a:t>
             </a:fld>
             <a:endParaRPr lang="en-US" dirty="0"/>
           </a:p>
@@ -25025,7 +25025,7 @@
           <a:p>
             <a:fld id="{4509A250-FF31-4206-8172-F9D3106AACB1}" type="datetimeFigureOut">
               <a:rPr lang="en-US" smtClean="0"/>
-              <a:t>6/1/2026</a:t>
+              <a:t>6/2/2026</a:t>
             </a:fld>
             <a:endParaRPr lang="en-US" dirty="0"/>
           </a:p>
@@ -25300,7 +25300,7 @@
           <a:p>
             <a:fld id="{4509A250-FF31-4206-8172-F9D3106AACB1}" type="datetimeFigureOut">
               <a:rPr lang="en-US" smtClean="0"/>
-              <a:t>6/1/2026</a:t>
+              <a:t>6/2/2026</a:t>
             </a:fld>
             <a:endParaRPr lang="en-US" dirty="0"/>
           </a:p>
@@ -25729,7 +25729,7 @@
           <a:p>
             <a:fld id="{4509A250-FF31-4206-8172-F9D3106AACB1}" type="datetimeFigureOut">
               <a:rPr lang="en-US" smtClean="0"/>
-              <a:t>6/1/2026</a:t>
+              <a:t>6/2/2026</a:t>
             </a:fld>
             <a:endParaRPr lang="en-US" dirty="0"/>
           </a:p>
@@ -30986,7 +30986,7 @@
           <p:nvPr>
             <p:extLst>
               <p:ext uri="{D42A27DB-BD31-4B8C-83A1-F6EECF244321}">
-                <p14:modId xmlns:p14="http://schemas.microsoft.com/office/powerpoint/2010/main" val="1816206148"/>
+                <p14:modId xmlns:p14="http://schemas.microsoft.com/office/powerpoint/2010/main" val="760571972"/>
               </p:ext>
             </p:extLst>
           </p:nvPr>

</xml_diff>